<commit_message>
Update presentation theme to Architectural Studio Light keynote style with high-contrast typography
</commit_message>
<xml_diff>
--- a/presentation/Swetha_Portfolio_Presentation.pptx
+++ b/presentation/Swetha_Portfolio_Presentation.pptx
@@ -3108,7 +3108,7 @@
             <a:avLst/>
           </a:prstGeom>
           <a:solidFill>
-            <a:srgbClr val="0B0F19"/>
+            <a:srgbClr val="F8FAFC"/>
           </a:solidFill>
           <a:ln>
             <a:noFill/>
@@ -3151,11 +3151,11 @@
             <a:avLst/>
           </a:prstGeom>
           <a:solidFill>
-            <a:srgbClr val="111827"/>
+            <a:srgbClr val="FFFFFF"/>
           </a:solidFill>
           <a:ln w="12700">
             <a:solidFill>
-              <a:srgbClr val="1F2937"/>
+              <a:srgbClr val="E2E8F0"/>
             </a:solidFill>
           </a:ln>
         </p:spPr>
@@ -3206,7 +3206,7 @@
             <a:pPr>
               <a:defRPr sz="1000" b="1">
                 <a:solidFill>
-                  <a:srgbClr val="6366F1"/>
+                  <a:srgbClr val="4F46E5"/>
                 </a:solidFill>
                 <a:latin typeface="Outfit"/>
               </a:defRPr>
@@ -3242,7 +3242,7 @@
             <a:pPr>
               <a:defRPr sz="3200" b="1">
                 <a:solidFill>
-                  <a:srgbClr val="F8FAFC"/>
+                  <a:srgbClr val="0F172A"/>
                 </a:solidFill>
                 <a:latin typeface="Outfit"/>
               </a:defRPr>
@@ -3282,7 +3282,7 @@
             <a:pPr>
               <a:defRPr sz="1300">
                 <a:solidFill>
-                  <a:srgbClr val="94A3B8"/>
+                  <a:srgbClr val="334155"/>
                 </a:solidFill>
                 <a:latin typeface="Inter"/>
               </a:defRPr>
@@ -3308,7 +3308,7 @@
             <a:avLst/>
           </a:prstGeom>
           <a:solidFill>
-            <a:srgbClr val="1F2937"/>
+            <a:srgbClr val="E2E8F0"/>
           </a:solidFill>
           <a:ln>
             <a:noFill/>
@@ -3361,7 +3361,7 @@
             <a:pPr>
               <a:defRPr sz="1500" b="1">
                 <a:solidFill>
-                  <a:srgbClr val="F8FAFC"/>
+                  <a:srgbClr val="0F172A"/>
                 </a:solidFill>
                 <a:latin typeface="Outfit"/>
               </a:defRPr>
@@ -3374,7 +3374,7 @@
             <a:pPr>
               <a:defRPr sz="1100">
                 <a:solidFill>
-                  <a:srgbClr val="94A3B8"/>
+                  <a:srgbClr val="334155"/>
                 </a:solidFill>
                 <a:latin typeface="Inter"/>
               </a:defRPr>
@@ -3387,7 +3387,7 @@
             <a:pPr>
               <a:defRPr sz="1100">
                 <a:solidFill>
-                  <a:srgbClr val="38BDF8"/>
+                  <a:srgbClr val="2563EB"/>
                 </a:solidFill>
                 <a:latin typeface="Inter"/>
               </a:defRPr>
@@ -3413,11 +3413,11 @@
             <a:avLst/>
           </a:prstGeom>
           <a:solidFill>
-            <a:srgbClr val="111827"/>
+            <a:srgbClr val="FFFFFF"/>
           </a:solidFill>
           <a:ln w="12700">
             <a:solidFill>
-              <a:srgbClr val="1F2937"/>
+              <a:srgbClr val="E2E8F0"/>
             </a:solidFill>
           </a:ln>
         </p:spPr>
@@ -3482,11 +3482,11 @@
             <a:avLst/>
           </a:prstGeom>
           <a:solidFill>
-            <a:srgbClr val="182135"/>
+            <a:srgbClr val="F1F5F9"/>
           </a:solidFill>
           <a:ln w="12700">
             <a:solidFill>
-              <a:srgbClr val="10B981"/>
+              <a:srgbClr val="E2E8F0"/>
             </a:solidFill>
           </a:ln>
         </p:spPr>
@@ -3511,13 +3511,13 @@
             <a:pPr algn="ctr">
               <a:defRPr sz="1000" b="1">
                 <a:solidFill>
-                  <a:srgbClr val="10B981"/>
+                  <a:srgbClr val="059669"/>
                 </a:solidFill>
                 <a:latin typeface="JetBrains Mono"/>
               </a:defRPr>
             </a:pPr>
             <a:r>
-              <a:t>● Live Build: my-portfolio-nine-psi-98.vercel.app</a:t>
+              <a:t>● Live Build: my-portfolio-swethanagaraj2007s-projects.vercel.app</a:t>
             </a:r>
           </a:p>
         </p:txBody>
@@ -3555,7 +3555,7 @@
             <a:avLst/>
           </a:prstGeom>
           <a:solidFill>
-            <a:srgbClr val="0B0F19"/>
+            <a:srgbClr val="F8FAFC"/>
           </a:solidFill>
           <a:ln>
             <a:noFill/>
@@ -3608,7 +3608,7 @@
             <a:pPr>
               <a:defRPr sz="1000" b="1">
                 <a:solidFill>
-                  <a:srgbClr val="6366F1"/>
+                  <a:srgbClr val="4F46E5"/>
                 </a:solidFill>
                 <a:latin typeface="Outfit"/>
               </a:defRPr>
@@ -3644,7 +3644,7 @@
             <a:pPr>
               <a:defRPr sz="2600" b="1">
                 <a:solidFill>
-                  <a:srgbClr val="F8FAFC"/>
+                  <a:srgbClr val="0F172A"/>
                 </a:solidFill>
                 <a:latin typeface="Outfit"/>
               </a:defRPr>
@@ -3680,7 +3680,7 @@
             <a:pPr>
               <a:defRPr sz="1300">
                 <a:solidFill>
-                  <a:srgbClr val="94A3B8"/>
+                  <a:srgbClr val="334155"/>
                 </a:solidFill>
                 <a:latin typeface="Inter"/>
               </a:defRPr>
@@ -3706,11 +3706,11 @@
             <a:avLst/>
           </a:prstGeom>
           <a:solidFill>
-            <a:srgbClr val="111827"/>
+            <a:srgbClr val="EEF2FF"/>
           </a:solidFill>
           <a:ln w="19050">
             <a:solidFill>
-              <a:srgbClr val="6366F1"/>
+              <a:srgbClr val="4F46E5"/>
             </a:solidFill>
           </a:ln>
         </p:spPr>
@@ -3735,7 +3735,7 @@
             <a:pPr algn="ctr">
               <a:defRPr sz="1000" b="1">
                 <a:solidFill>
-                  <a:srgbClr val="38BDF8"/>
+                  <a:srgbClr val="4F46E5"/>
                 </a:solidFill>
                 <a:latin typeface="Outfit"/>
               </a:defRPr>
@@ -3751,7 +3751,7 @@
               </a:spcBef>
               <a:defRPr sz="1600" b="1">
                 <a:solidFill>
-                  <a:srgbClr val="F8FAFC"/>
+                  <a:srgbClr val="0F172A"/>
                 </a:solidFill>
                 <a:latin typeface="Outfit"/>
               </a:defRPr>
@@ -3767,7 +3767,7 @@
               </a:spcBef>
               <a:defRPr sz="1200">
                 <a:solidFill>
-                  <a:srgbClr val="94A3B8"/>
+                  <a:srgbClr val="334155"/>
                 </a:solidFill>
                 <a:latin typeface="Inter"/>
               </a:defRPr>
@@ -3793,11 +3793,11 @@
             <a:avLst/>
           </a:prstGeom>
           <a:solidFill>
-            <a:srgbClr val="111827"/>
+            <a:srgbClr val="FFFFFF"/>
           </a:solidFill>
           <a:ln w="12700">
             <a:solidFill>
-              <a:srgbClr val="1F2937"/>
+              <a:srgbClr val="E2E8F0"/>
             </a:solidFill>
           </a:ln>
         </p:spPr>
@@ -3822,7 +3822,7 @@
             <a:pPr algn="ctr">
               <a:defRPr sz="1800" b="1">
                 <a:solidFill>
-                  <a:srgbClr val="6366F1"/>
+                  <a:srgbClr val="4F46E5"/>
                 </a:solidFill>
                 <a:latin typeface="JetBrains Mono"/>
               </a:defRPr>
@@ -3838,7 +3838,7 @@
               </a:spcBef>
               <a:defRPr sz="1400" b="1">
                 <a:solidFill>
-                  <a:srgbClr val="F8FAFC"/>
+                  <a:srgbClr val="0F172A"/>
                 </a:solidFill>
                 <a:latin typeface="Outfit"/>
               </a:defRPr>
@@ -3854,7 +3854,7 @@
               </a:spcBef>
               <a:defRPr sz="1100">
                 <a:solidFill>
-                  <a:srgbClr val="94A3B8"/>
+                  <a:srgbClr val="334155"/>
                 </a:solidFill>
                 <a:latin typeface="Inter"/>
               </a:defRPr>
@@ -3880,7 +3880,7 @@
             <a:avLst/>
           </a:prstGeom>
           <a:solidFill>
-            <a:srgbClr val="6366F1"/>
+            <a:srgbClr val="4F46E5"/>
           </a:solidFill>
           <a:ln>
             <a:noFill/>
@@ -3923,11 +3923,11 @@
             <a:avLst/>
           </a:prstGeom>
           <a:solidFill>
-            <a:srgbClr val="111827"/>
+            <a:srgbClr val="FFFFFF"/>
           </a:solidFill>
           <a:ln w="12700">
             <a:solidFill>
-              <a:srgbClr val="1F2937"/>
+              <a:srgbClr val="E2E8F0"/>
             </a:solidFill>
           </a:ln>
         </p:spPr>
@@ -3952,7 +3952,7 @@
             <a:pPr algn="ctr">
               <a:defRPr sz="1800" b="1">
                 <a:solidFill>
-                  <a:srgbClr val="10B981"/>
+                  <a:srgbClr val="059669"/>
                 </a:solidFill>
                 <a:latin typeface="JetBrains Mono"/>
               </a:defRPr>
@@ -3968,7 +3968,7 @@
               </a:spcBef>
               <a:defRPr sz="1400" b="1">
                 <a:solidFill>
-                  <a:srgbClr val="F8FAFC"/>
+                  <a:srgbClr val="0F172A"/>
                 </a:solidFill>
                 <a:latin typeface="Outfit"/>
               </a:defRPr>
@@ -3984,7 +3984,7 @@
               </a:spcBef>
               <a:defRPr sz="1100">
                 <a:solidFill>
-                  <a:srgbClr val="94A3B8"/>
+                  <a:srgbClr val="334155"/>
                 </a:solidFill>
                 <a:latin typeface="Inter"/>
               </a:defRPr>
@@ -4010,7 +4010,7 @@
             <a:avLst/>
           </a:prstGeom>
           <a:solidFill>
-            <a:srgbClr val="10B981"/>
+            <a:srgbClr val="059669"/>
           </a:solidFill>
           <a:ln>
             <a:noFill/>
@@ -4053,11 +4053,11 @@
             <a:avLst/>
           </a:prstGeom>
           <a:solidFill>
-            <a:srgbClr val="111827"/>
+            <a:srgbClr val="FFFFFF"/>
           </a:solidFill>
           <a:ln w="12700">
             <a:solidFill>
-              <a:srgbClr val="1F2937"/>
+              <a:srgbClr val="E2E8F0"/>
             </a:solidFill>
           </a:ln>
         </p:spPr>
@@ -4082,7 +4082,7 @@
             <a:pPr algn="ctr">
               <a:defRPr sz="1800" b="1">
                 <a:solidFill>
-                  <a:srgbClr val="38BDF8"/>
+                  <a:srgbClr val="2563EB"/>
                 </a:solidFill>
                 <a:latin typeface="JetBrains Mono"/>
               </a:defRPr>
@@ -4098,7 +4098,7 @@
               </a:spcBef>
               <a:defRPr sz="1400" b="1">
                 <a:solidFill>
-                  <a:srgbClr val="F8FAFC"/>
+                  <a:srgbClr val="0F172A"/>
                 </a:solidFill>
                 <a:latin typeface="Outfit"/>
               </a:defRPr>
@@ -4114,7 +4114,7 @@
               </a:spcBef>
               <a:defRPr sz="1100">
                 <a:solidFill>
-                  <a:srgbClr val="94A3B8"/>
+                  <a:srgbClr val="334155"/>
                 </a:solidFill>
                 <a:latin typeface="Inter"/>
               </a:defRPr>
@@ -4140,7 +4140,7 @@
             <a:avLst/>
           </a:prstGeom>
           <a:solidFill>
-            <a:srgbClr val="38BDF8"/>
+            <a:srgbClr val="2563EB"/>
           </a:solidFill>
           <a:ln>
             <a:noFill/>
@@ -4201,7 +4201,7 @@
             <a:avLst/>
           </a:prstGeom>
           <a:solidFill>
-            <a:srgbClr val="0B0F19"/>
+            <a:srgbClr val="F8FAFC"/>
           </a:solidFill>
           <a:ln>
             <a:noFill/>
@@ -4254,7 +4254,7 @@
             <a:pPr>
               <a:defRPr sz="1000" b="1">
                 <a:solidFill>
-                  <a:srgbClr val="6366F1"/>
+                  <a:srgbClr val="4F46E5"/>
                 </a:solidFill>
                 <a:latin typeface="Outfit"/>
               </a:defRPr>
@@ -4290,7 +4290,7 @@
             <a:pPr>
               <a:defRPr sz="2600" b="1">
                 <a:solidFill>
-                  <a:srgbClr val="F8FAFC"/>
+                  <a:srgbClr val="0F172A"/>
                 </a:solidFill>
                 <a:latin typeface="Outfit"/>
               </a:defRPr>
@@ -4326,7 +4326,7 @@
             <a:pPr>
               <a:defRPr sz="1300">
                 <a:solidFill>
-                  <a:srgbClr val="94A3B8"/>
+                  <a:srgbClr val="334155"/>
                 </a:solidFill>
                 <a:latin typeface="Inter"/>
               </a:defRPr>
@@ -4352,11 +4352,11 @@
             <a:avLst/>
           </a:prstGeom>
           <a:solidFill>
-            <a:srgbClr val="111827"/>
+            <a:srgbClr val="FFFFFF"/>
           </a:solidFill>
           <a:ln w="15240">
             <a:solidFill>
-              <a:srgbClr val="6366F1"/>
+              <a:srgbClr val="4F46E5"/>
             </a:solidFill>
           </a:ln>
         </p:spPr>
@@ -4381,7 +4381,7 @@
             <a:pPr algn="ctr">
               <a:defRPr sz="1000" b="1">
                 <a:solidFill>
-                  <a:srgbClr val="38BDF8"/>
+                  <a:srgbClr val="2563EB"/>
                 </a:solidFill>
                 <a:latin typeface="JetBrains Mono"/>
               </a:defRPr>
@@ -4397,7 +4397,7 @@
               </a:spcBef>
               <a:defRPr sz="1300" b="1">
                 <a:solidFill>
-                  <a:srgbClr val="F8FAFC"/>
+                  <a:srgbClr val="0F172A"/>
                 </a:solidFill>
                 <a:latin typeface="Outfit"/>
               </a:defRPr>
@@ -4413,7 +4413,7 @@
               </a:spcBef>
               <a:defRPr sz="850">
                 <a:solidFill>
-                  <a:srgbClr val="94A3B8"/>
+                  <a:srgbClr val="334155"/>
                 </a:solidFill>
                 <a:latin typeface="Inter"/>
               </a:defRPr>
@@ -4439,11 +4439,11 @@
             <a:avLst/>
           </a:prstGeom>
           <a:solidFill>
-            <a:srgbClr val="111827"/>
+            <a:srgbClr val="FFFFFF"/>
           </a:solidFill>
           <a:ln w="15240">
             <a:solidFill>
-              <a:srgbClr val="1F2937"/>
+              <a:srgbClr val="E2E8F0"/>
             </a:solidFill>
           </a:ln>
         </p:spPr>
@@ -4468,7 +4468,7 @@
             <a:pPr algn="ctr">
               <a:defRPr sz="1000" b="1">
                 <a:solidFill>
-                  <a:srgbClr val="38BDF8"/>
+                  <a:srgbClr val="2563EB"/>
                 </a:solidFill>
                 <a:latin typeface="JetBrains Mono"/>
               </a:defRPr>
@@ -4484,7 +4484,7 @@
               </a:spcBef>
               <a:defRPr sz="1300" b="1">
                 <a:solidFill>
-                  <a:srgbClr val="F8FAFC"/>
+                  <a:srgbClr val="0F172A"/>
                 </a:solidFill>
                 <a:latin typeface="Outfit"/>
               </a:defRPr>
@@ -4500,7 +4500,7 @@
               </a:spcBef>
               <a:defRPr sz="850">
                 <a:solidFill>
-                  <a:srgbClr val="94A3B8"/>
+                  <a:srgbClr val="334155"/>
                 </a:solidFill>
                 <a:latin typeface="Inter"/>
               </a:defRPr>
@@ -4526,11 +4526,11 @@
             <a:avLst/>
           </a:prstGeom>
           <a:solidFill>
-            <a:srgbClr val="111827"/>
+            <a:srgbClr val="FFFFFF"/>
           </a:solidFill>
           <a:ln w="15240">
             <a:solidFill>
-              <a:srgbClr val="1F2937"/>
+              <a:srgbClr val="E2E8F0"/>
             </a:solidFill>
           </a:ln>
         </p:spPr>
@@ -4555,7 +4555,7 @@
             <a:pPr algn="ctr">
               <a:defRPr sz="1000" b="1">
                 <a:solidFill>
-                  <a:srgbClr val="38BDF8"/>
+                  <a:srgbClr val="2563EB"/>
                 </a:solidFill>
                 <a:latin typeface="JetBrains Mono"/>
               </a:defRPr>
@@ -4571,7 +4571,7 @@
               </a:spcBef>
               <a:defRPr sz="1300" b="1">
                 <a:solidFill>
-                  <a:srgbClr val="F8FAFC"/>
+                  <a:srgbClr val="0F172A"/>
                 </a:solidFill>
                 <a:latin typeface="Outfit"/>
               </a:defRPr>
@@ -4587,7 +4587,7 @@
               </a:spcBef>
               <a:defRPr sz="850">
                 <a:solidFill>
-                  <a:srgbClr val="94A3B8"/>
+                  <a:srgbClr val="334155"/>
                 </a:solidFill>
                 <a:latin typeface="Inter"/>
               </a:defRPr>
@@ -4613,11 +4613,11 @@
             <a:avLst/>
           </a:prstGeom>
           <a:solidFill>
-            <a:srgbClr val="111827"/>
+            <a:srgbClr val="FFFFFF"/>
           </a:solidFill>
           <a:ln w="15240">
             <a:solidFill>
-              <a:srgbClr val="6366F1"/>
+              <a:srgbClr val="4F46E5"/>
             </a:solidFill>
           </a:ln>
         </p:spPr>
@@ -4642,7 +4642,7 @@
             <a:pPr algn="ctr">
               <a:defRPr sz="1000" b="1">
                 <a:solidFill>
-                  <a:srgbClr val="38BDF8"/>
+                  <a:srgbClr val="2563EB"/>
                 </a:solidFill>
                 <a:latin typeface="JetBrains Mono"/>
               </a:defRPr>
@@ -4658,7 +4658,7 @@
               </a:spcBef>
               <a:defRPr sz="1300" b="1">
                 <a:solidFill>
-                  <a:srgbClr val="F8FAFC"/>
+                  <a:srgbClr val="0F172A"/>
                 </a:solidFill>
                 <a:latin typeface="Outfit"/>
               </a:defRPr>
@@ -4674,7 +4674,7 @@
               </a:spcBef>
               <a:defRPr sz="850">
                 <a:solidFill>
-                  <a:srgbClr val="94A3B8"/>
+                  <a:srgbClr val="334155"/>
                 </a:solidFill>
                 <a:latin typeface="Inter"/>
               </a:defRPr>
@@ -4700,11 +4700,11 @@
             <a:avLst/>
           </a:prstGeom>
           <a:solidFill>
-            <a:srgbClr val="111827"/>
+            <a:srgbClr val="FFFFFF"/>
           </a:solidFill>
           <a:ln w="15240">
             <a:solidFill>
-              <a:srgbClr val="6366F1"/>
+              <a:srgbClr val="4F46E5"/>
             </a:solidFill>
           </a:ln>
         </p:spPr>
@@ -4729,7 +4729,7 @@
             <a:pPr algn="ctr">
               <a:defRPr sz="1000" b="1">
                 <a:solidFill>
-                  <a:srgbClr val="38BDF8"/>
+                  <a:srgbClr val="2563EB"/>
                 </a:solidFill>
                 <a:latin typeface="JetBrains Mono"/>
               </a:defRPr>
@@ -4745,7 +4745,7 @@
               </a:spcBef>
               <a:defRPr sz="1300" b="1">
                 <a:solidFill>
-                  <a:srgbClr val="F8FAFC"/>
+                  <a:srgbClr val="0F172A"/>
                 </a:solidFill>
                 <a:latin typeface="Outfit"/>
               </a:defRPr>
@@ -4761,7 +4761,7 @@
               </a:spcBef>
               <a:defRPr sz="850">
                 <a:solidFill>
-                  <a:srgbClr val="94A3B8"/>
+                  <a:srgbClr val="334155"/>
                 </a:solidFill>
                 <a:latin typeface="Inter"/>
               </a:defRPr>
@@ -4787,11 +4787,11 @@
             <a:avLst/>
           </a:prstGeom>
           <a:solidFill>
-            <a:srgbClr val="111827"/>
+            <a:srgbClr val="FFFFFF"/>
           </a:solidFill>
           <a:ln w="15240">
             <a:solidFill>
-              <a:srgbClr val="1F2937"/>
+              <a:srgbClr val="E2E8F0"/>
             </a:solidFill>
           </a:ln>
         </p:spPr>
@@ -4816,7 +4816,7 @@
             <a:pPr algn="ctr">
               <a:defRPr sz="1000" b="1">
                 <a:solidFill>
-                  <a:srgbClr val="38BDF8"/>
+                  <a:srgbClr val="2563EB"/>
                 </a:solidFill>
                 <a:latin typeface="JetBrains Mono"/>
               </a:defRPr>
@@ -4832,7 +4832,7 @@
               </a:spcBef>
               <a:defRPr sz="1300" b="1">
                 <a:solidFill>
-                  <a:srgbClr val="F8FAFC"/>
+                  <a:srgbClr val="0F172A"/>
                 </a:solidFill>
                 <a:latin typeface="Outfit"/>
               </a:defRPr>
@@ -4848,7 +4848,7 @@
               </a:spcBef>
               <a:defRPr sz="850">
                 <a:solidFill>
-                  <a:srgbClr val="94A3B8"/>
+                  <a:srgbClr val="334155"/>
                 </a:solidFill>
                 <a:latin typeface="Inter"/>
               </a:defRPr>
@@ -4874,11 +4874,11 @@
             <a:avLst/>
           </a:prstGeom>
           <a:solidFill>
-            <a:srgbClr val="111827"/>
+            <a:srgbClr val="FFFFFF"/>
           </a:solidFill>
           <a:ln w="15240">
             <a:solidFill>
-              <a:srgbClr val="1F2937"/>
+              <a:srgbClr val="E2E8F0"/>
             </a:solidFill>
           </a:ln>
         </p:spPr>
@@ -4903,7 +4903,7 @@
             <a:pPr algn="ctr">
               <a:defRPr sz="1000" b="1">
                 <a:solidFill>
-                  <a:srgbClr val="38BDF8"/>
+                  <a:srgbClr val="2563EB"/>
                 </a:solidFill>
                 <a:latin typeface="JetBrains Mono"/>
               </a:defRPr>
@@ -4919,7 +4919,7 @@
               </a:spcBef>
               <a:defRPr sz="1300" b="1">
                 <a:solidFill>
-                  <a:srgbClr val="F8FAFC"/>
+                  <a:srgbClr val="0F172A"/>
                 </a:solidFill>
                 <a:latin typeface="Outfit"/>
               </a:defRPr>
@@ -4935,7 +4935,7 @@
               </a:spcBef>
               <a:defRPr sz="850">
                 <a:solidFill>
-                  <a:srgbClr val="94A3B8"/>
+                  <a:srgbClr val="334155"/>
                 </a:solidFill>
                 <a:latin typeface="Inter"/>
               </a:defRPr>
@@ -4961,11 +4961,11 @@
             <a:avLst/>
           </a:prstGeom>
           <a:solidFill>
-            <a:srgbClr val="111827"/>
+            <a:srgbClr val="FFFFFF"/>
           </a:solidFill>
           <a:ln w="12700">
             <a:solidFill>
-              <a:srgbClr val="1F2937"/>
+              <a:srgbClr val="E2E8F0"/>
             </a:solidFill>
           </a:ln>
         </p:spPr>
@@ -4990,7 +4990,7 @@
             <a:pPr algn="ctr">
               <a:defRPr sz="1400" b="1">
                 <a:solidFill>
-                  <a:srgbClr val="F8FAFC"/>
+                  <a:srgbClr val="0F172A"/>
                 </a:solidFill>
                 <a:latin typeface="Outfit"/>
               </a:defRPr>
@@ -5006,7 +5006,7 @@
               </a:spcBef>
               <a:defRPr sz="1100">
                 <a:solidFill>
-                  <a:srgbClr val="94A3B8"/>
+                  <a:srgbClr val="334155"/>
                 </a:solidFill>
                 <a:latin typeface="Inter"/>
               </a:defRPr>
@@ -5032,7 +5032,7 @@
             <a:avLst/>
           </a:prstGeom>
           <a:solidFill>
-            <a:srgbClr val="38BDF8"/>
+            <a:srgbClr val="2563EB"/>
           </a:solidFill>
           <a:ln>
             <a:noFill/>
@@ -5075,11 +5075,11 @@
             <a:avLst/>
           </a:prstGeom>
           <a:solidFill>
-            <a:srgbClr val="111827"/>
+            <a:srgbClr val="FFFFFF"/>
           </a:solidFill>
           <a:ln w="12700">
             <a:solidFill>
-              <a:srgbClr val="1F2937"/>
+              <a:srgbClr val="E2E8F0"/>
             </a:solidFill>
           </a:ln>
         </p:spPr>
@@ -5104,7 +5104,7 @@
             <a:pPr algn="ctr">
               <a:defRPr sz="1400" b="1">
                 <a:solidFill>
-                  <a:srgbClr val="F8FAFC"/>
+                  <a:srgbClr val="0F172A"/>
                 </a:solidFill>
                 <a:latin typeface="Outfit"/>
               </a:defRPr>
@@ -5120,7 +5120,7 @@
               </a:spcBef>
               <a:defRPr sz="1100">
                 <a:solidFill>
-                  <a:srgbClr val="94A3B8"/>
+                  <a:srgbClr val="334155"/>
                 </a:solidFill>
                 <a:latin typeface="Inter"/>
               </a:defRPr>
@@ -5146,7 +5146,7 @@
             <a:avLst/>
           </a:prstGeom>
           <a:solidFill>
-            <a:srgbClr val="6366F1"/>
+            <a:srgbClr val="4F46E5"/>
           </a:solidFill>
           <a:ln>
             <a:noFill/>
@@ -5189,11 +5189,11 @@
             <a:avLst/>
           </a:prstGeom>
           <a:solidFill>
-            <a:srgbClr val="111827"/>
+            <a:srgbClr val="FFFFFF"/>
           </a:solidFill>
           <a:ln w="12700">
             <a:solidFill>
-              <a:srgbClr val="1F2937"/>
+              <a:srgbClr val="E2E8F0"/>
             </a:solidFill>
           </a:ln>
         </p:spPr>
@@ -5218,7 +5218,7 @@
             <a:pPr algn="ctr">
               <a:defRPr sz="1400" b="1">
                 <a:solidFill>
-                  <a:srgbClr val="F8FAFC"/>
+                  <a:srgbClr val="0F172A"/>
                 </a:solidFill>
                 <a:latin typeface="Outfit"/>
               </a:defRPr>
@@ -5234,7 +5234,7 @@
               </a:spcBef>
               <a:defRPr sz="1100">
                 <a:solidFill>
-                  <a:srgbClr val="94A3B8"/>
+                  <a:srgbClr val="334155"/>
                 </a:solidFill>
                 <a:latin typeface="Inter"/>
               </a:defRPr>
@@ -5260,7 +5260,7 @@
             <a:avLst/>
           </a:prstGeom>
           <a:solidFill>
-            <a:srgbClr val="10B981"/>
+            <a:srgbClr val="059669"/>
           </a:solidFill>
           <a:ln>
             <a:noFill/>
@@ -5321,7 +5321,7 @@
             <a:avLst/>
           </a:prstGeom>
           <a:solidFill>
-            <a:srgbClr val="0B0F19"/>
+            <a:srgbClr val="F8FAFC"/>
           </a:solidFill>
           <a:ln>
             <a:noFill/>
@@ -5374,7 +5374,7 @@
             <a:pPr>
               <a:defRPr sz="1000" b="1">
                 <a:solidFill>
-                  <a:srgbClr val="6366F1"/>
+                  <a:srgbClr val="4F46E5"/>
                 </a:solidFill>
                 <a:latin typeface="Outfit"/>
               </a:defRPr>
@@ -5410,7 +5410,7 @@
             <a:pPr>
               <a:defRPr sz="2600" b="1">
                 <a:solidFill>
-                  <a:srgbClr val="F8FAFC"/>
+                  <a:srgbClr val="0F172A"/>
                 </a:solidFill>
                 <a:latin typeface="Outfit"/>
               </a:defRPr>
@@ -5446,7 +5446,7 @@
             <a:pPr>
               <a:defRPr sz="1300">
                 <a:solidFill>
-                  <a:srgbClr val="94A3B8"/>
+                  <a:srgbClr val="334155"/>
                 </a:solidFill>
                 <a:latin typeface="Inter"/>
               </a:defRPr>
@@ -5472,11 +5472,11 @@
             <a:avLst/>
           </a:prstGeom>
           <a:solidFill>
-            <a:srgbClr val="111827"/>
+            <a:srgbClr val="FFFFFF"/>
           </a:solidFill>
           <a:ln w="12700">
             <a:solidFill>
-              <a:srgbClr val="1F2937"/>
+              <a:srgbClr val="E2E8F0"/>
             </a:solidFill>
           </a:ln>
         </p:spPr>
@@ -5501,7 +5501,7 @@
             <a:pPr algn="ctr">
               <a:defRPr sz="950" b="1">
                 <a:solidFill>
-                  <a:srgbClr val="10B981"/>
+                  <a:srgbClr val="059669"/>
                 </a:solidFill>
                 <a:latin typeface="JetBrains Mono"/>
               </a:defRPr>
@@ -5520,7 +5520,7 @@
               </a:spcAft>
               <a:defRPr sz="1600" b="1">
                 <a:solidFill>
-                  <a:srgbClr val="F8FAFC"/>
+                  <a:srgbClr val="0F172A"/>
                 </a:solidFill>
                 <a:latin typeface="Outfit"/>
               </a:defRPr>
@@ -5536,7 +5536,7 @@
               </a:spcAft>
               <a:defRPr sz="1050">
                 <a:solidFill>
-                  <a:srgbClr val="94A3B8"/>
+                  <a:srgbClr val="334155"/>
                 </a:solidFill>
                 <a:latin typeface="Inter"/>
               </a:defRPr>
@@ -5552,7 +5552,7 @@
               </a:spcAft>
               <a:defRPr sz="1050">
                 <a:solidFill>
-                  <a:srgbClr val="94A3B8"/>
+                  <a:srgbClr val="334155"/>
                 </a:solidFill>
                 <a:latin typeface="Inter"/>
               </a:defRPr>
@@ -5568,7 +5568,7 @@
               </a:spcAft>
               <a:defRPr sz="1050">
                 <a:solidFill>
-                  <a:srgbClr val="94A3B8"/>
+                  <a:srgbClr val="334155"/>
                 </a:solidFill>
                 <a:latin typeface="Inter"/>
               </a:defRPr>
@@ -5594,7 +5594,7 @@
             <a:avLst/>
           </a:prstGeom>
           <a:solidFill>
-            <a:srgbClr val="10B981"/>
+            <a:srgbClr val="059669"/>
           </a:solidFill>
           <a:ln>
             <a:noFill/>
@@ -5637,11 +5637,11 @@
             <a:avLst/>
           </a:prstGeom>
           <a:solidFill>
-            <a:srgbClr val="111827"/>
+            <a:srgbClr val="FFFFFF"/>
           </a:solidFill>
           <a:ln w="12700">
             <a:solidFill>
-              <a:srgbClr val="1F2937"/>
+              <a:srgbClr val="E2E8F0"/>
             </a:solidFill>
           </a:ln>
         </p:spPr>
@@ -5666,7 +5666,7 @@
             <a:pPr algn="ctr">
               <a:defRPr sz="950" b="1">
                 <a:solidFill>
-                  <a:srgbClr val="38BDF8"/>
+                  <a:srgbClr val="2563EB"/>
                 </a:solidFill>
                 <a:latin typeface="JetBrains Mono"/>
               </a:defRPr>
@@ -5685,7 +5685,7 @@
               </a:spcAft>
               <a:defRPr sz="1600" b="1">
                 <a:solidFill>
-                  <a:srgbClr val="F8FAFC"/>
+                  <a:srgbClr val="0F172A"/>
                 </a:solidFill>
                 <a:latin typeface="Outfit"/>
               </a:defRPr>
@@ -5701,7 +5701,7 @@
               </a:spcAft>
               <a:defRPr sz="1050">
                 <a:solidFill>
-                  <a:srgbClr val="94A3B8"/>
+                  <a:srgbClr val="334155"/>
                 </a:solidFill>
                 <a:latin typeface="Inter"/>
               </a:defRPr>
@@ -5717,7 +5717,7 @@
               </a:spcAft>
               <a:defRPr sz="1050">
                 <a:solidFill>
-                  <a:srgbClr val="94A3B8"/>
+                  <a:srgbClr val="334155"/>
                 </a:solidFill>
                 <a:latin typeface="Inter"/>
               </a:defRPr>
@@ -5733,7 +5733,7 @@
               </a:spcAft>
               <a:defRPr sz="1050">
                 <a:solidFill>
-                  <a:srgbClr val="94A3B8"/>
+                  <a:srgbClr val="334155"/>
                 </a:solidFill>
                 <a:latin typeface="Inter"/>
               </a:defRPr>
@@ -5759,7 +5759,7 @@
             <a:avLst/>
           </a:prstGeom>
           <a:solidFill>
-            <a:srgbClr val="38BDF8"/>
+            <a:srgbClr val="2563EB"/>
           </a:solidFill>
           <a:ln>
             <a:noFill/>
@@ -5802,11 +5802,11 @@
             <a:avLst/>
           </a:prstGeom>
           <a:solidFill>
-            <a:srgbClr val="111827"/>
+            <a:srgbClr val="FFFFFF"/>
           </a:solidFill>
           <a:ln w="12700">
             <a:solidFill>
-              <a:srgbClr val="1F2937"/>
+              <a:srgbClr val="E2E8F0"/>
             </a:solidFill>
           </a:ln>
         </p:spPr>
@@ -5831,7 +5831,7 @@
             <a:pPr algn="ctr">
               <a:defRPr sz="950" b="1">
                 <a:solidFill>
-                  <a:srgbClr val="6366F1"/>
+                  <a:srgbClr val="4F46E5"/>
                 </a:solidFill>
                 <a:latin typeface="JetBrains Mono"/>
               </a:defRPr>
@@ -5850,7 +5850,7 @@
               </a:spcAft>
               <a:defRPr sz="1600" b="1">
                 <a:solidFill>
-                  <a:srgbClr val="F8FAFC"/>
+                  <a:srgbClr val="0F172A"/>
                 </a:solidFill>
                 <a:latin typeface="Outfit"/>
               </a:defRPr>
@@ -5866,7 +5866,7 @@
               </a:spcAft>
               <a:defRPr sz="1050">
                 <a:solidFill>
-                  <a:srgbClr val="94A3B8"/>
+                  <a:srgbClr val="334155"/>
                 </a:solidFill>
                 <a:latin typeface="Inter"/>
               </a:defRPr>
@@ -5882,7 +5882,7 @@
               </a:spcAft>
               <a:defRPr sz="1050">
                 <a:solidFill>
-                  <a:srgbClr val="94A3B8"/>
+                  <a:srgbClr val="334155"/>
                 </a:solidFill>
                 <a:latin typeface="Inter"/>
               </a:defRPr>
@@ -5898,7 +5898,7 @@
               </a:spcAft>
               <a:defRPr sz="1050">
                 <a:solidFill>
-                  <a:srgbClr val="94A3B8"/>
+                  <a:srgbClr val="334155"/>
                 </a:solidFill>
                 <a:latin typeface="Inter"/>
               </a:defRPr>
@@ -5924,7 +5924,7 @@
             <a:avLst/>
           </a:prstGeom>
           <a:solidFill>
-            <a:srgbClr val="6366F1"/>
+            <a:srgbClr val="4F46E5"/>
           </a:solidFill>
           <a:ln>
             <a:noFill/>
@@ -5967,11 +5967,11 @@
             <a:avLst/>
           </a:prstGeom>
           <a:solidFill>
-            <a:srgbClr val="111827"/>
+            <a:srgbClr val="FFFFFF"/>
           </a:solidFill>
           <a:ln w="12700">
             <a:solidFill>
-              <a:srgbClr val="1F2937"/>
+              <a:srgbClr val="E2E8F0"/>
             </a:solidFill>
           </a:ln>
         </p:spPr>
@@ -5996,7 +5996,7 @@
             <a:pPr algn="ctr">
               <a:defRPr sz="950" b="1">
                 <a:solidFill>
-                  <a:srgbClr val="A855F7"/>
+                  <a:srgbClr val="7C3AED"/>
                 </a:solidFill>
                 <a:latin typeface="JetBrains Mono"/>
               </a:defRPr>
@@ -6015,7 +6015,7 @@
               </a:spcAft>
               <a:defRPr sz="1600" b="1">
                 <a:solidFill>
-                  <a:srgbClr val="F8FAFC"/>
+                  <a:srgbClr val="0F172A"/>
                 </a:solidFill>
                 <a:latin typeface="Outfit"/>
               </a:defRPr>
@@ -6031,7 +6031,7 @@
               </a:spcAft>
               <a:defRPr sz="1050">
                 <a:solidFill>
-                  <a:srgbClr val="94A3B8"/>
+                  <a:srgbClr val="334155"/>
                 </a:solidFill>
                 <a:latin typeface="Inter"/>
               </a:defRPr>
@@ -6047,7 +6047,7 @@
               </a:spcAft>
               <a:defRPr sz="1050">
                 <a:solidFill>
-                  <a:srgbClr val="94A3B8"/>
+                  <a:srgbClr val="334155"/>
                 </a:solidFill>
                 <a:latin typeface="Inter"/>
               </a:defRPr>
@@ -6063,7 +6063,7 @@
               </a:spcAft>
               <a:defRPr sz="1050">
                 <a:solidFill>
-                  <a:srgbClr val="94A3B8"/>
+                  <a:srgbClr val="334155"/>
                 </a:solidFill>
                 <a:latin typeface="Inter"/>
               </a:defRPr>
@@ -6089,7 +6089,7 @@
             <a:avLst/>
           </a:prstGeom>
           <a:solidFill>
-            <a:srgbClr val="A855F7"/>
+            <a:srgbClr val="7C3AED"/>
           </a:solidFill>
           <a:ln>
             <a:noFill/>
@@ -6150,7 +6150,7 @@
             <a:avLst/>
           </a:prstGeom>
           <a:solidFill>
-            <a:srgbClr val="0B0F19"/>
+            <a:srgbClr val="F8FAFC"/>
           </a:solidFill>
           <a:ln>
             <a:noFill/>
@@ -6203,7 +6203,7 @@
             <a:pPr>
               <a:defRPr sz="1000" b="1">
                 <a:solidFill>
-                  <a:srgbClr val="6366F1"/>
+                  <a:srgbClr val="4F46E5"/>
                 </a:solidFill>
                 <a:latin typeface="Outfit"/>
               </a:defRPr>
@@ -6239,7 +6239,7 @@
             <a:pPr>
               <a:defRPr sz="2600" b="1">
                 <a:solidFill>
-                  <a:srgbClr val="F8FAFC"/>
+                  <a:srgbClr val="0F172A"/>
                 </a:solidFill>
                 <a:latin typeface="Outfit"/>
               </a:defRPr>
@@ -6275,7 +6275,7 @@
             <a:pPr>
               <a:defRPr sz="1300">
                 <a:solidFill>
-                  <a:srgbClr val="94A3B8"/>
+                  <a:srgbClr val="334155"/>
                 </a:solidFill>
                 <a:latin typeface="Inter"/>
               </a:defRPr>
@@ -6301,11 +6301,11 @@
             <a:avLst/>
           </a:prstGeom>
           <a:solidFill>
-            <a:srgbClr val="111827"/>
+            <a:srgbClr val="FFFFFF"/>
           </a:solidFill>
           <a:ln w="12700">
             <a:solidFill>
-              <a:srgbClr val="1F2937"/>
+              <a:srgbClr val="E2E8F0"/>
             </a:solidFill>
           </a:ln>
         </p:spPr>
@@ -6383,7 +6383,7 @@
               </a:spcAft>
               <a:defRPr sz="1400" b="1">
                 <a:solidFill>
-                  <a:srgbClr val="38BDF8"/>
+                  <a:srgbClr val="2563EB"/>
                 </a:solidFill>
                 <a:latin typeface="Outfit"/>
               </a:defRPr>
@@ -6396,7 +6396,7 @@
             <a:pPr>
               <a:defRPr sz="1050">
                 <a:solidFill>
-                  <a:srgbClr val="94A3B8"/>
+                  <a:srgbClr val="334155"/>
                 </a:solidFill>
                 <a:latin typeface="Inter"/>
               </a:defRPr>
@@ -6422,11 +6422,11 @@
             <a:avLst/>
           </a:prstGeom>
           <a:solidFill>
-            <a:srgbClr val="111827"/>
+            <a:srgbClr val="FFFFFF"/>
           </a:solidFill>
           <a:ln w="12700">
             <a:solidFill>
-              <a:srgbClr val="1F2937"/>
+              <a:srgbClr val="E2E8F0"/>
             </a:solidFill>
           </a:ln>
         </p:spPr>
@@ -6504,7 +6504,7 @@
               </a:spcAft>
               <a:defRPr sz="1400" b="1">
                 <a:solidFill>
-                  <a:srgbClr val="38BDF8"/>
+                  <a:srgbClr val="2563EB"/>
                 </a:solidFill>
                 <a:latin typeface="Outfit"/>
               </a:defRPr>
@@ -6517,13 +6517,13 @@
             <a:pPr>
               <a:defRPr sz="1050">
                 <a:solidFill>
-                  <a:srgbClr val="94A3B8"/>
+                  <a:srgbClr val="334155"/>
                 </a:solidFill>
                 <a:latin typeface="Inter"/>
               </a:defRPr>
             </a:pPr>
             <a:r>
-              <a:t>Deep engineering breakdowns: Zoho OpenAPI RAG Assistant, Healthcare EHR, and Smart SMS Extension.</a:t>
+              <a:t>Deep engineering breakdowns: Zoho OpenAPI RAG Assistant, Healthcare EHR, and Smart SMS Django Platform.</a:t>
             </a:r>
           </a:p>
         </p:txBody>
@@ -6561,7 +6561,7 @@
             <a:avLst/>
           </a:prstGeom>
           <a:solidFill>
-            <a:srgbClr val="0B0F19"/>
+            <a:srgbClr val="F8FAFC"/>
           </a:solidFill>
           <a:ln>
             <a:noFill/>
@@ -6614,7 +6614,7 @@
             <a:pPr>
               <a:defRPr sz="1000" b="1">
                 <a:solidFill>
-                  <a:srgbClr val="6366F1"/>
+                  <a:srgbClr val="4F46E5"/>
                 </a:solidFill>
                 <a:latin typeface="Outfit"/>
               </a:defRPr>
@@ -6650,7 +6650,7 @@
             <a:pPr>
               <a:defRPr sz="2600" b="1">
                 <a:solidFill>
-                  <a:srgbClr val="F8FAFC"/>
+                  <a:srgbClr val="0F172A"/>
                 </a:solidFill>
                 <a:latin typeface="Outfit"/>
               </a:defRPr>
@@ -6686,7 +6686,7 @@
             <a:pPr>
               <a:defRPr sz="1300">
                 <a:solidFill>
-                  <a:srgbClr val="94A3B8"/>
+                  <a:srgbClr val="334155"/>
                 </a:solidFill>
                 <a:latin typeface="Inter"/>
               </a:defRPr>
@@ -6712,11 +6712,11 @@
             <a:avLst/>
           </a:prstGeom>
           <a:solidFill>
-            <a:srgbClr val="111827"/>
+            <a:srgbClr val="FFFFFF"/>
           </a:solidFill>
           <a:ln w="12700">
             <a:solidFill>
-              <a:srgbClr val="1F2937"/>
+              <a:srgbClr val="E2E8F0"/>
             </a:solidFill>
           </a:ln>
         </p:spPr>
@@ -6741,7 +6741,7 @@
             <a:pPr algn="ctr">
               <a:defRPr sz="1100" b="1">
                 <a:solidFill>
-                  <a:srgbClr val="10B981"/>
+                  <a:srgbClr val="059669"/>
                 </a:solidFill>
                 <a:latin typeface="JetBrains Mono"/>
               </a:defRPr>
@@ -6757,7 +6757,7 @@
               </a:spcBef>
               <a:defRPr sz="1300" b="1">
                 <a:solidFill>
-                  <a:srgbClr val="F8FAFC"/>
+                  <a:srgbClr val="0F172A"/>
                 </a:solidFill>
                 <a:latin typeface="Outfit"/>
               </a:defRPr>
@@ -6770,7 +6770,7 @@
             <a:pPr>
               <a:defRPr sz="1050">
                 <a:solidFill>
-                  <a:srgbClr val="94A3B8"/>
+                  <a:srgbClr val="334155"/>
                 </a:solidFill>
                 <a:latin typeface="Inter"/>
               </a:defRPr>
@@ -6786,7 +6786,7 @@
               </a:spcBef>
               <a:defRPr sz="1300" b="1">
                 <a:solidFill>
-                  <a:srgbClr val="F8FAFC"/>
+                  <a:srgbClr val="0F172A"/>
                 </a:solidFill>
                 <a:latin typeface="Outfit"/>
               </a:defRPr>
@@ -6799,7 +6799,7 @@
             <a:pPr>
               <a:defRPr sz="1050">
                 <a:solidFill>
-                  <a:srgbClr val="94A3B8"/>
+                  <a:srgbClr val="334155"/>
                 </a:solidFill>
                 <a:latin typeface="Inter"/>
               </a:defRPr>
@@ -6815,7 +6815,7 @@
               </a:spcBef>
               <a:defRPr sz="1300" b="1">
                 <a:solidFill>
-                  <a:srgbClr val="F8FAFC"/>
+                  <a:srgbClr val="0F172A"/>
                 </a:solidFill>
                 <a:latin typeface="Outfit"/>
               </a:defRPr>
@@ -6828,7 +6828,7 @@
             <a:pPr>
               <a:defRPr sz="1050">
                 <a:solidFill>
-                  <a:srgbClr val="94A3B8"/>
+                  <a:srgbClr val="334155"/>
                 </a:solidFill>
                 <a:latin typeface="Inter"/>
               </a:defRPr>
@@ -6844,7 +6844,7 @@
               </a:spcBef>
               <a:defRPr sz="1300" b="1">
                 <a:solidFill>
-                  <a:srgbClr val="F8FAFC"/>
+                  <a:srgbClr val="0F172A"/>
                 </a:solidFill>
                 <a:latin typeface="Outfit"/>
               </a:defRPr>
@@ -6857,7 +6857,7 @@
             <a:pPr>
               <a:defRPr sz="1050">
                 <a:solidFill>
-                  <a:srgbClr val="94A3B8"/>
+                  <a:srgbClr val="334155"/>
                 </a:solidFill>
                 <a:latin typeface="Inter"/>
               </a:defRPr>
@@ -6883,7 +6883,7 @@
             <a:avLst/>
           </a:prstGeom>
           <a:solidFill>
-            <a:srgbClr val="10B981"/>
+            <a:srgbClr val="059669"/>
           </a:solidFill>
           <a:ln>
             <a:noFill/>
@@ -6926,11 +6926,11 @@
             <a:avLst/>
           </a:prstGeom>
           <a:solidFill>
-            <a:srgbClr val="111827"/>
+            <a:srgbClr val="FFFFFF"/>
           </a:solidFill>
           <a:ln w="12700">
             <a:solidFill>
-              <a:srgbClr val="1F2937"/>
+              <a:srgbClr val="E2E8F0"/>
             </a:solidFill>
           </a:ln>
         </p:spPr>
@@ -6955,7 +6955,7 @@
             <a:pPr algn="ctr">
               <a:defRPr sz="1100" b="1">
                 <a:solidFill>
-                  <a:srgbClr val="6366F1"/>
+                  <a:srgbClr val="4F46E5"/>
                 </a:solidFill>
                 <a:latin typeface="JetBrains Mono"/>
               </a:defRPr>
@@ -6971,7 +6971,7 @@
               </a:spcBef>
               <a:defRPr sz="1250" b="1">
                 <a:solidFill>
-                  <a:srgbClr val="F8FAFC"/>
+                  <a:srgbClr val="0F172A"/>
                 </a:solidFill>
                 <a:latin typeface="Outfit"/>
               </a:defRPr>
@@ -6984,7 +6984,7 @@
             <a:pPr>
               <a:defRPr sz="1050">
                 <a:solidFill>
-                  <a:srgbClr val="94A3B8"/>
+                  <a:srgbClr val="334155"/>
                 </a:solidFill>
                 <a:latin typeface="Inter"/>
               </a:defRPr>
@@ -7000,7 +7000,7 @@
               </a:spcBef>
               <a:defRPr sz="1250" b="1">
                 <a:solidFill>
-                  <a:srgbClr val="F8FAFC"/>
+                  <a:srgbClr val="0F172A"/>
                 </a:solidFill>
                 <a:latin typeface="Outfit"/>
               </a:defRPr>
@@ -7013,7 +7013,7 @@
             <a:pPr>
               <a:defRPr sz="1050">
                 <a:solidFill>
-                  <a:srgbClr val="94A3B8"/>
+                  <a:srgbClr val="334155"/>
                 </a:solidFill>
                 <a:latin typeface="Inter"/>
               </a:defRPr>
@@ -7039,7 +7039,7 @@
             <a:avLst/>
           </a:prstGeom>
           <a:solidFill>
-            <a:srgbClr val="6366F1"/>
+            <a:srgbClr val="4F46E5"/>
           </a:solidFill>
           <a:ln>
             <a:noFill/>
@@ -7082,11 +7082,11 @@
             <a:avLst/>
           </a:prstGeom>
           <a:solidFill>
-            <a:srgbClr val="182135"/>
+            <a:srgbClr val="EEF2FF"/>
           </a:solidFill>
           <a:ln w="19050">
             <a:solidFill>
-              <a:srgbClr val="6366F1"/>
+              <a:srgbClr val="4F46E5"/>
             </a:solidFill>
           </a:ln>
         </p:spPr>
@@ -7111,7 +7111,7 @@
             <a:pPr algn="ctr">
               <a:defRPr sz="2200" b="1">
                 <a:solidFill>
-                  <a:srgbClr val="F8FAFC"/>
+                  <a:srgbClr val="0F172A"/>
                 </a:solidFill>
                 <a:latin typeface="Outfit"/>
               </a:defRPr>
@@ -7127,7 +7127,7 @@
               </a:spcBef>
               <a:defRPr sz="1200" b="1">
                 <a:solidFill>
-                  <a:srgbClr val="38BDF8"/>
+                  <a:srgbClr val="2563EB"/>
                 </a:solidFill>
                 <a:latin typeface="Inter"/>
               </a:defRPr>
@@ -7140,7 +7140,7 @@
             <a:pPr algn="ctr">
               <a:defRPr sz="1050">
                 <a:solidFill>
-                  <a:srgbClr val="64748B"/>
+                  <a:srgbClr val="334155"/>
                 </a:solidFill>
                 <a:latin typeface="Inter"/>
               </a:defRPr>

</xml_diff>

<commit_message>
Refine presentation deck: remove cover screenshot, add dedicated Thank You slide, upgrade to architectural light theme
</commit_message>
<xml_diff>
--- a/presentation/Swetha_Portfolio_Presentation.pptx
+++ b/presentation/Swetha_Portfolio_Presentation.pptx
@@ -11,6 +11,7 @@
     <p:sldId id="259" r:id="rId10"/>
     <p:sldId id="260" r:id="rId11"/>
     <p:sldId id="261" r:id="rId12"/>
+    <p:sldId id="262" r:id="rId13"/>
   </p:sldIdLst>
   <p:sldSz cx="12191695" cy="6858000" type="screen4x3"/>
   <p:notesSz cx="6858000" cy="9144000"/>
@@ -3144,8 +3145,8 @@
         </p:nvSpPr>
         <p:spPr>
           <a:xfrm>
-            <a:off x="822960" y="822960"/>
-            <a:ext cx="5120640" cy="5212080"/>
+            <a:off x="822960" y="777240"/>
+            <a:ext cx="10545775" cy="5303520"/>
           </a:xfrm>
           <a:prstGeom prst="roundRect">
             <a:avLst/>
@@ -3183,36 +3184,55 @@
       </p:sp>
       <p:sp>
         <p:nvSpPr>
-          <p:cNvPr id="4" name="TextBox 3"/>
-          <p:cNvSpPr txBox="1"/>
+          <p:cNvPr id="4" name="Rounded Rectangle 3"/>
+          <p:cNvSpPr/>
           <p:nvPr/>
         </p:nvSpPr>
         <p:spPr>
           <a:xfrm>
-            <a:off x="1188720" y="1188720"/>
-            <a:ext cx="4389120" cy="320040"/>
-          </a:xfrm>
-          <a:prstGeom prst="rect">
-            <a:avLst/>
-          </a:prstGeom>
-          <a:noFill/>
-        </p:spPr>
-        <p:txBody>
-          <a:bodyPr wrap="none">
-            <a:spAutoFit/>
-          </a:bodyPr>
-          <a:lstStyle/>
-          <a:p>
-            <a:pPr>
-              <a:defRPr sz="1000" b="1">
+            <a:off x="1371600" y="1188720"/>
+            <a:ext cx="4114800" cy="384048"/>
+          </a:xfrm>
+          <a:prstGeom prst="roundRect">
+            <a:avLst/>
+          </a:prstGeom>
+          <a:solidFill>
+            <a:srgbClr val="EEF2FF"/>
+          </a:solidFill>
+          <a:ln w="12700">
+            <a:solidFill>
+              <a:srgbClr val="93C5FD"/>
+            </a:solidFill>
+          </a:ln>
+        </p:spPr>
+        <p:style>
+          <a:lnRef idx="1">
+            <a:schemeClr val="accent1"/>
+          </a:lnRef>
+          <a:fillRef idx="3">
+            <a:schemeClr val="accent1"/>
+          </a:fillRef>
+          <a:effectRef idx="2">
+            <a:schemeClr val="accent1"/>
+          </a:effectRef>
+          <a:fontRef idx="minor">
+            <a:schemeClr val="lt1"/>
+          </a:fontRef>
+        </p:style>
+        <p:txBody>
+          <a:bodyPr rtlCol="0" anchor="ctr"/>
+          <a:lstStyle/>
+          <a:p>
+            <a:pPr algn="ctr">
+              <a:defRPr sz="950" b="1">
                 <a:solidFill>
                   <a:srgbClr val="4F46E5"/>
                 </a:solidFill>
-                <a:latin typeface="Outfit"/>
-              </a:defRPr>
-            </a:pPr>
-            <a:r>
-              <a:t>PORTFOLIO &amp; TECHNICAL CAPSTONE</a:t>
+                <a:latin typeface="JetBrains Mono"/>
+              </a:defRPr>
+            </a:pPr>
+            <a:r>
+              <a:t>ACADEMIC CAPSTONE &amp; TECHNICAL EVALUATION</a:t>
             </a:r>
           </a:p>
         </p:txBody>
@@ -3225,8 +3245,8 @@
         </p:nvSpPr>
         <p:spPr>
           <a:xfrm>
-            <a:off x="1188720" y="1554480"/>
-            <a:ext cx="4389120" cy="1645920"/>
+            <a:off x="1371600" y="1783080"/>
+            <a:ext cx="9448495" cy="1463040"/>
           </a:xfrm>
           <a:prstGeom prst="rect">
             <a:avLst/>
@@ -3240,7 +3260,7 @@
           <a:lstStyle/>
           <a:p>
             <a:pPr>
-              <a:defRPr sz="3200" b="1">
+              <a:defRPr sz="3800" b="1">
                 <a:solidFill>
                   <a:srgbClr val="0F172A"/>
                 </a:solidFill>
@@ -3248,11 +3268,7 @@
               </a:defRPr>
             </a:pPr>
             <a:r>
-              <a:t>Personal Developer</a:t>
-            </a:r>
-            <a:br/>
-            <a:r>
-              <a:t>Portfolio Website</a:t>
+              <a:t>Personal Developer Portfolio Website</a:t>
             </a:r>
           </a:p>
         </p:txBody>
@@ -3265,8 +3281,8 @@
         </p:nvSpPr>
         <p:spPr>
           <a:xfrm>
-            <a:off x="1188720" y="3291840"/>
-            <a:ext cx="4389120" cy="914400"/>
+            <a:off x="1371600" y="2697480"/>
+            <a:ext cx="8961120" cy="731520"/>
           </a:xfrm>
           <a:prstGeom prst="rect">
             <a:avLst/>
@@ -3280,7 +3296,7 @@
           <a:lstStyle/>
           <a:p>
             <a:pPr>
-              <a:defRPr sz="1300">
+              <a:defRPr sz="1400">
                 <a:solidFill>
                   <a:srgbClr val="334155"/>
                 </a:solidFill>
@@ -3288,7 +3304,7 @@
               </a:defRPr>
             </a:pPr>
             <a:r>
-              <a:t>A digital showcase bridging Computer Science fundamentals with human-centered design.</a:t>
+              <a:t>A production-grade digital platform engineered with semantic web standards, applied RAG intelligence, and human-centered design principles.</a:t>
             </a:r>
           </a:p>
         </p:txBody>
@@ -3301,8 +3317,8 @@
         </p:nvSpPr>
         <p:spPr>
           <a:xfrm>
-            <a:off x="1188720" y="4297680"/>
-            <a:ext cx="4389120" cy="18288"/>
+            <a:off x="1371600" y="3566160"/>
+            <a:ext cx="9448495" cy="18288"/>
           </a:xfrm>
           <a:prstGeom prst="rect">
             <a:avLst/>
@@ -3338,145 +3354,14 @@
       </p:sp>
       <p:sp>
         <p:nvSpPr>
-          <p:cNvPr id="8" name="TextBox 7"/>
-          <p:cNvSpPr txBox="1"/>
-          <p:nvPr/>
-        </p:nvSpPr>
-        <p:spPr>
-          <a:xfrm>
-            <a:off x="1188720" y="4434840"/>
-            <a:ext cx="4389120" cy="1280160"/>
-          </a:xfrm>
-          <a:prstGeom prst="rect">
-            <a:avLst/>
-          </a:prstGeom>
-          <a:noFill/>
-        </p:spPr>
-        <p:txBody>
-          <a:bodyPr wrap="square">
-            <a:spAutoFit/>
-          </a:bodyPr>
-          <a:lstStyle/>
-          <a:p>
-            <a:pPr>
-              <a:defRPr sz="1500" b="1">
-                <a:solidFill>
-                  <a:srgbClr val="0F172A"/>
-                </a:solidFill>
-                <a:latin typeface="Outfit"/>
-              </a:defRPr>
-            </a:pPr>
-            <a:r>
-              <a:t>Swetha N.</a:t>
-            </a:r>
-          </a:p>
-          <a:p>
-            <a:pPr>
-              <a:defRPr sz="1100">
-                <a:solidFill>
-                  <a:srgbClr val="334155"/>
-                </a:solidFill>
-                <a:latin typeface="Inter"/>
-              </a:defRPr>
-            </a:pPr>
-            <a:r>
-              <a:t>B.E. Computer Science and Design (Class of 2028)</a:t>
-            </a:r>
-          </a:p>
-          <a:p>
-            <a:pPr>
-              <a:defRPr sz="1100">
-                <a:solidFill>
-                  <a:srgbClr val="2563EB"/>
-                </a:solidFill>
-                <a:latin typeface="Inter"/>
-              </a:defRPr>
-            </a:pPr>
-            <a:r>
-              <a:t>Rajalakshmi Engineering College, Chennai</a:t>
-            </a:r>
-          </a:p>
-        </p:txBody>
-      </p:sp>
-      <p:sp>
-        <p:nvSpPr>
-          <p:cNvPr id="9" name="Rounded Rectangle 8"/>
+          <p:cNvPr id="8" name="Rounded Rectangle 7"/>
           <p:cNvSpPr/>
           <p:nvPr/>
         </p:nvSpPr>
         <p:spPr>
           <a:xfrm>
-            <a:off x="6217920" y="822960"/>
-            <a:ext cx="5150815" cy="5212080"/>
-          </a:xfrm>
-          <a:prstGeom prst="roundRect">
-            <a:avLst/>
-          </a:prstGeom>
-          <a:solidFill>
-            <a:srgbClr val="FFFFFF"/>
-          </a:solidFill>
-          <a:ln w="12700">
-            <a:solidFill>
-              <a:srgbClr val="E2E8F0"/>
-            </a:solidFill>
-          </a:ln>
-        </p:spPr>
-        <p:style>
-          <a:lnRef idx="1">
-            <a:schemeClr val="accent1"/>
-          </a:lnRef>
-          <a:fillRef idx="3">
-            <a:schemeClr val="accent1"/>
-          </a:fillRef>
-          <a:effectRef idx="2">
-            <a:schemeClr val="accent1"/>
-          </a:effectRef>
-          <a:fontRef idx="minor">
-            <a:schemeClr val="lt1"/>
-          </a:fontRef>
-        </p:style>
-        <p:txBody>
-          <a:bodyPr rtlCol="0" anchor="ctr"/>
-          <a:lstStyle/>
-          <a:p>
-            <a:pPr algn="ctr"/>
-          </a:p>
-        </p:txBody>
-      </p:sp>
-      <p:pic>
-        <p:nvPicPr>
-          <p:cNvPr id="10" name="Picture 9" descr="01_hero.png"/>
-          <p:cNvPicPr>
-            <a:picLocks noChangeAspect="1"/>
-          </p:cNvPicPr>
-          <p:nvPr/>
-        </p:nvPicPr>
-        <p:blipFill>
-          <a:blip r:embed="rId2"/>
-          <a:stretch>
-            <a:fillRect/>
-          </a:stretch>
-        </p:blipFill>
-        <p:spPr>
-          <a:xfrm>
-            <a:off x="6309360" y="914400"/>
-            <a:ext cx="4967935" cy="4297680"/>
-          </a:xfrm>
-          <a:prstGeom prst="rect">
-            <a:avLst/>
-          </a:prstGeom>
-        </p:spPr>
-      </p:pic>
-      <p:sp>
-        <p:nvSpPr>
-          <p:cNvPr id="11" name="Rounded Rectangle 10"/>
-          <p:cNvSpPr/>
-          <p:nvPr/>
-        </p:nvSpPr>
-        <p:spPr>
-          <a:xfrm>
-            <a:off x="6309360" y="5394960"/>
-            <a:ext cx="4967935" cy="502920"/>
+            <a:off x="1371600" y="3794760"/>
+            <a:ext cx="2240280" cy="1828800"/>
           </a:xfrm>
           <a:prstGeom prst="roundRect">
             <a:avLst/>
@@ -3505,11 +3390,271 @@
           </a:fontRef>
         </p:style>
         <p:txBody>
+          <a:bodyPr rtlCol="0" anchor="ctr" wrap="square"/>
+          <a:lstStyle/>
+          <a:p>
+            <a:pPr algn="ctr">
+              <a:defRPr sz="900" b="1">
+                <a:solidFill>
+                  <a:srgbClr val="4F46E5"/>
+                </a:solidFill>
+                <a:latin typeface="JetBrains Mono"/>
+              </a:defRPr>
+            </a:pPr>
+            <a:r>
+              <a:t>PRESENTER</a:t>
+            </a:r>
+          </a:p>
+          <a:p>
+            <a:pPr>
+              <a:spcBef>
+                <a:spcPts val="600"/>
+              </a:spcBef>
+              <a:defRPr sz="1300" b="1">
+                <a:solidFill>
+                  <a:srgbClr val="0F172A"/>
+                </a:solidFill>
+                <a:latin typeface="Outfit"/>
+              </a:defRPr>
+            </a:pPr>
+            <a:r>
+              <a:t>Swetha N.</a:t>
+            </a:r>
+          </a:p>
+          <a:p>
+            <a:pPr>
+              <a:spcBef>
+                <a:spcPts val="400"/>
+              </a:spcBef>
+              <a:defRPr sz="950">
+                <a:solidFill>
+                  <a:srgbClr val="64748B"/>
+                </a:solidFill>
+                <a:latin typeface="Inter"/>
+              </a:defRPr>
+            </a:pPr>
+            <a:r>
+              <a:t>B.E. Computer Science and Design</a:t>
+            </a:r>
+          </a:p>
+        </p:txBody>
+      </p:sp>
+      <p:sp>
+        <p:nvSpPr>
+          <p:cNvPr id="9" name="Rectangle 8"/>
+          <p:cNvSpPr/>
+          <p:nvPr/>
+        </p:nvSpPr>
+        <p:spPr>
+          <a:xfrm>
+            <a:off x="1371600" y="3794760"/>
+            <a:ext cx="2240280" cy="36576"/>
+          </a:xfrm>
+          <a:prstGeom prst="rect">
+            <a:avLst/>
+          </a:prstGeom>
+          <a:solidFill>
+            <a:srgbClr val="4F46E5"/>
+          </a:solidFill>
+          <a:ln>
+            <a:noFill/>
+          </a:ln>
+        </p:spPr>
+        <p:style>
+          <a:lnRef idx="1">
+            <a:schemeClr val="accent1"/>
+          </a:lnRef>
+          <a:fillRef idx="3">
+            <a:schemeClr val="accent1"/>
+          </a:fillRef>
+          <a:effectRef idx="2">
+            <a:schemeClr val="accent1"/>
+          </a:effectRef>
+          <a:fontRef idx="minor">
+            <a:schemeClr val="lt1"/>
+          </a:fontRef>
+        </p:style>
+        <p:txBody>
           <a:bodyPr rtlCol="0" anchor="ctr"/>
           <a:lstStyle/>
           <a:p>
+            <a:pPr algn="ctr"/>
+          </a:p>
+        </p:txBody>
+      </p:sp>
+      <p:sp>
+        <p:nvSpPr>
+          <p:cNvPr id="10" name="Rounded Rectangle 9"/>
+          <p:cNvSpPr/>
+          <p:nvPr/>
+        </p:nvSpPr>
+        <p:spPr>
+          <a:xfrm>
+            <a:off x="3794760" y="3794760"/>
+            <a:ext cx="2240280" cy="1828800"/>
+          </a:xfrm>
+          <a:prstGeom prst="roundRect">
+            <a:avLst/>
+          </a:prstGeom>
+          <a:solidFill>
+            <a:srgbClr val="F1F5F9"/>
+          </a:solidFill>
+          <a:ln w="12700">
+            <a:solidFill>
+              <a:srgbClr val="E2E8F0"/>
+            </a:solidFill>
+          </a:ln>
+        </p:spPr>
+        <p:style>
+          <a:lnRef idx="1">
+            <a:schemeClr val="accent1"/>
+          </a:lnRef>
+          <a:fillRef idx="3">
+            <a:schemeClr val="accent1"/>
+          </a:fillRef>
+          <a:effectRef idx="2">
+            <a:schemeClr val="accent1"/>
+          </a:effectRef>
+          <a:fontRef idx="minor">
+            <a:schemeClr val="lt1"/>
+          </a:fontRef>
+        </p:style>
+        <p:txBody>
+          <a:bodyPr rtlCol="0" anchor="ctr" wrap="square"/>
+          <a:lstStyle/>
+          <a:p>
             <a:pPr algn="ctr">
-              <a:defRPr sz="1000" b="1">
+              <a:defRPr sz="900" b="1">
+                <a:solidFill>
+                  <a:srgbClr val="2563EB"/>
+                </a:solidFill>
+                <a:latin typeface="JetBrains Mono"/>
+              </a:defRPr>
+            </a:pPr>
+            <a:r>
+              <a:t>INSTITUTION</a:t>
+            </a:r>
+          </a:p>
+          <a:p>
+            <a:pPr>
+              <a:spcBef>
+                <a:spcPts val="600"/>
+              </a:spcBef>
+              <a:defRPr sz="1300" b="1">
+                <a:solidFill>
+                  <a:srgbClr val="0F172A"/>
+                </a:solidFill>
+                <a:latin typeface="Outfit"/>
+              </a:defRPr>
+            </a:pPr>
+            <a:r>
+              <a:t>Rajalakshmi Eng. College</a:t>
+            </a:r>
+          </a:p>
+          <a:p>
+            <a:pPr>
+              <a:spcBef>
+                <a:spcPts val="400"/>
+              </a:spcBef>
+              <a:defRPr sz="950">
+                <a:solidFill>
+                  <a:srgbClr val="64748B"/>
+                </a:solidFill>
+                <a:latin typeface="Inter"/>
+              </a:defRPr>
+            </a:pPr>
+            <a:r>
+              <a:t>Chennai · Class of 2028 (CGPA: 8.65)</a:t>
+            </a:r>
+          </a:p>
+        </p:txBody>
+      </p:sp>
+      <p:sp>
+        <p:nvSpPr>
+          <p:cNvPr id="11" name="Rectangle 10"/>
+          <p:cNvSpPr/>
+          <p:nvPr/>
+        </p:nvSpPr>
+        <p:spPr>
+          <a:xfrm>
+            <a:off x="3794760" y="3794760"/>
+            <a:ext cx="2240280" cy="36576"/>
+          </a:xfrm>
+          <a:prstGeom prst="rect">
+            <a:avLst/>
+          </a:prstGeom>
+          <a:solidFill>
+            <a:srgbClr val="2563EB"/>
+          </a:solidFill>
+          <a:ln>
+            <a:noFill/>
+          </a:ln>
+        </p:spPr>
+        <p:style>
+          <a:lnRef idx="1">
+            <a:schemeClr val="accent1"/>
+          </a:lnRef>
+          <a:fillRef idx="3">
+            <a:schemeClr val="accent1"/>
+          </a:fillRef>
+          <a:effectRef idx="2">
+            <a:schemeClr val="accent1"/>
+          </a:effectRef>
+          <a:fontRef idx="minor">
+            <a:schemeClr val="lt1"/>
+          </a:fontRef>
+        </p:style>
+        <p:txBody>
+          <a:bodyPr rtlCol="0" anchor="ctr"/>
+          <a:lstStyle/>
+          <a:p>
+            <a:pPr algn="ctr"/>
+          </a:p>
+        </p:txBody>
+      </p:sp>
+      <p:sp>
+        <p:nvSpPr>
+          <p:cNvPr id="12" name="Rounded Rectangle 11"/>
+          <p:cNvSpPr/>
+          <p:nvPr/>
+        </p:nvSpPr>
+        <p:spPr>
+          <a:xfrm>
+            <a:off x="6217920" y="3794760"/>
+            <a:ext cx="2240280" cy="1828800"/>
+          </a:xfrm>
+          <a:prstGeom prst="roundRect">
+            <a:avLst/>
+          </a:prstGeom>
+          <a:solidFill>
+            <a:srgbClr val="F1F5F9"/>
+          </a:solidFill>
+          <a:ln w="12700">
+            <a:solidFill>
+              <a:srgbClr val="E2E8F0"/>
+            </a:solidFill>
+          </a:ln>
+        </p:spPr>
+        <p:style>
+          <a:lnRef idx="1">
+            <a:schemeClr val="accent1"/>
+          </a:lnRef>
+          <a:fillRef idx="3">
+            <a:schemeClr val="accent1"/>
+          </a:fillRef>
+          <a:effectRef idx="2">
+            <a:schemeClr val="accent1"/>
+          </a:effectRef>
+          <a:fontRef idx="minor">
+            <a:schemeClr val="lt1"/>
+          </a:fontRef>
+        </p:style>
+        <p:txBody>
+          <a:bodyPr rtlCol="0" anchor="ctr" wrap="square"/>
+          <a:lstStyle/>
+          <a:p>
+            <a:pPr algn="ctr">
+              <a:defRPr sz="900" b="1">
                 <a:solidFill>
                   <a:srgbClr val="059669"/>
                 </a:solidFill>
@@ -3517,8 +3662,213 @@
               </a:defRPr>
             </a:pPr>
             <a:r>
-              <a:t>● Live Build: my-portfolio-swethanagaraj2007s-projects.vercel.app</a:t>
-            </a:r>
+              <a:t>CORE DOMAINS</a:t>
+            </a:r>
+          </a:p>
+          <a:p>
+            <a:pPr>
+              <a:spcBef>
+                <a:spcPts val="600"/>
+              </a:spcBef>
+              <a:defRPr sz="1300" b="1">
+                <a:solidFill>
+                  <a:srgbClr val="0F172A"/>
+                </a:solidFill>
+                <a:latin typeface="Outfit"/>
+              </a:defRPr>
+            </a:pPr>
+            <a:r>
+              <a:t>Backend &amp; Applied AI</a:t>
+            </a:r>
+          </a:p>
+          <a:p>
+            <a:pPr>
+              <a:spcBef>
+                <a:spcPts val="400"/>
+              </a:spcBef>
+              <a:defRPr sz="950">
+                <a:solidFill>
+                  <a:srgbClr val="64748B"/>
+                </a:solidFill>
+                <a:latin typeface="Inter"/>
+              </a:defRPr>
+            </a:pPr>
+            <a:r>
+              <a:t>RAG · Spring Boot · Django · Systems</a:t>
+            </a:r>
+          </a:p>
+        </p:txBody>
+      </p:sp>
+      <p:sp>
+        <p:nvSpPr>
+          <p:cNvPr id="13" name="Rectangle 12"/>
+          <p:cNvSpPr/>
+          <p:nvPr/>
+        </p:nvSpPr>
+        <p:spPr>
+          <a:xfrm>
+            <a:off x="6217920" y="3794760"/>
+            <a:ext cx="2240280" cy="36576"/>
+          </a:xfrm>
+          <a:prstGeom prst="rect">
+            <a:avLst/>
+          </a:prstGeom>
+          <a:solidFill>
+            <a:srgbClr val="059669"/>
+          </a:solidFill>
+          <a:ln>
+            <a:noFill/>
+          </a:ln>
+        </p:spPr>
+        <p:style>
+          <a:lnRef idx="1">
+            <a:schemeClr val="accent1"/>
+          </a:lnRef>
+          <a:fillRef idx="3">
+            <a:schemeClr val="accent1"/>
+          </a:fillRef>
+          <a:effectRef idx="2">
+            <a:schemeClr val="accent1"/>
+          </a:effectRef>
+          <a:fontRef idx="minor">
+            <a:schemeClr val="lt1"/>
+          </a:fontRef>
+        </p:style>
+        <p:txBody>
+          <a:bodyPr rtlCol="0" anchor="ctr"/>
+          <a:lstStyle/>
+          <a:p>
+            <a:pPr algn="ctr"/>
+          </a:p>
+        </p:txBody>
+      </p:sp>
+      <p:sp>
+        <p:nvSpPr>
+          <p:cNvPr id="14" name="Rounded Rectangle 13"/>
+          <p:cNvSpPr/>
+          <p:nvPr/>
+        </p:nvSpPr>
+        <p:spPr>
+          <a:xfrm>
+            <a:off x="8641080" y="3794760"/>
+            <a:ext cx="2240280" cy="1828800"/>
+          </a:xfrm>
+          <a:prstGeom prst="roundRect">
+            <a:avLst/>
+          </a:prstGeom>
+          <a:solidFill>
+            <a:srgbClr val="F1F5F9"/>
+          </a:solidFill>
+          <a:ln w="12700">
+            <a:solidFill>
+              <a:srgbClr val="E2E8F0"/>
+            </a:solidFill>
+          </a:ln>
+        </p:spPr>
+        <p:style>
+          <a:lnRef idx="1">
+            <a:schemeClr val="accent1"/>
+          </a:lnRef>
+          <a:fillRef idx="3">
+            <a:schemeClr val="accent1"/>
+          </a:fillRef>
+          <a:effectRef idx="2">
+            <a:schemeClr val="accent1"/>
+          </a:effectRef>
+          <a:fontRef idx="minor">
+            <a:schemeClr val="lt1"/>
+          </a:fontRef>
+        </p:style>
+        <p:txBody>
+          <a:bodyPr rtlCol="0" anchor="ctr" wrap="square"/>
+          <a:lstStyle/>
+          <a:p>
+            <a:pPr algn="ctr">
+              <a:defRPr sz="900" b="1">
+                <a:solidFill>
+                  <a:srgbClr val="7C3AED"/>
+                </a:solidFill>
+                <a:latin typeface="JetBrains Mono"/>
+              </a:defRPr>
+            </a:pPr>
+            <a:r>
+              <a:t>LIVE PLATFORM</a:t>
+            </a:r>
+          </a:p>
+          <a:p>
+            <a:pPr>
+              <a:spcBef>
+                <a:spcPts val="600"/>
+              </a:spcBef>
+              <a:defRPr sz="1300" b="1">
+                <a:solidFill>
+                  <a:srgbClr val="0F172A"/>
+                </a:solidFill>
+                <a:latin typeface="Outfit"/>
+              </a:defRPr>
+            </a:pPr>
+            <a:r>
+              <a:t>Verified Production CDN</a:t>
+            </a:r>
+          </a:p>
+          <a:p>
+            <a:pPr>
+              <a:spcBef>
+                <a:spcPts val="400"/>
+              </a:spcBef>
+              <a:defRPr sz="950">
+                <a:solidFill>
+                  <a:srgbClr val="64748B"/>
+                </a:solidFill>
+                <a:latin typeface="Inter"/>
+              </a:defRPr>
+            </a:pPr>
+            <a:r>
+              <a:t>my-portfolio-...vercel.app</a:t>
+            </a:r>
+          </a:p>
+        </p:txBody>
+      </p:sp>
+      <p:sp>
+        <p:nvSpPr>
+          <p:cNvPr id="15" name="Rectangle 14"/>
+          <p:cNvSpPr/>
+          <p:nvPr/>
+        </p:nvSpPr>
+        <p:spPr>
+          <a:xfrm>
+            <a:off x="8641080" y="3794760"/>
+            <a:ext cx="2240280" cy="36576"/>
+          </a:xfrm>
+          <a:prstGeom prst="rect">
+            <a:avLst/>
+          </a:prstGeom>
+          <a:solidFill>
+            <a:srgbClr val="7C3AED"/>
+          </a:solidFill>
+          <a:ln>
+            <a:noFill/>
+          </a:ln>
+        </p:spPr>
+        <p:style>
+          <a:lnRef idx="1">
+            <a:schemeClr val="accent1"/>
+          </a:lnRef>
+          <a:fillRef idx="3">
+            <a:schemeClr val="accent1"/>
+          </a:fillRef>
+          <a:effectRef idx="2">
+            <a:schemeClr val="accent1"/>
+          </a:effectRef>
+          <a:fontRef idx="minor">
+            <a:schemeClr val="lt1"/>
+          </a:fontRef>
+        </p:style>
+        <p:txBody>
+          <a:bodyPr rtlCol="0" anchor="ctr"/>
+          <a:lstStyle/>
+          <a:p>
+            <a:pPr algn="ctr"/>
           </a:p>
         </p:txBody>
       </p:sp>
@@ -6961,15 +7311,15 @@
               </a:defRPr>
             </a:pPr>
             <a:r>
-              <a:t>FUTURE ROADMAP</a:t>
+              <a:t>FUTURE ENGINEERING ROADMAP</a:t>
             </a:r>
           </a:p>
           <a:p>
             <a:pPr>
               <a:spcBef>
-                <a:spcPts val="600"/>
+                <a:spcPts val="800"/>
               </a:spcBef>
-              <a:defRPr sz="1250" b="1">
+              <a:defRPr sz="1300" b="1">
                 <a:solidFill>
                   <a:srgbClr val="0F172A"/>
                 </a:solidFill>
@@ -6977,7 +7327,7 @@
               </a:defRPr>
             </a:pPr>
             <a:r>
-              <a:t>→ Live LeetCode GraphQL Sync</a:t>
+              <a:t>→ Live LeetCode &amp; GitHub Sync</a:t>
             </a:r>
           </a:p>
           <a:p>
@@ -6990,15 +7340,15 @@
               </a:defRPr>
             </a:pPr>
             <a:r>
-              <a:t>Dynamic pipeline updating active problem counts and streak heatmaps automatically.</a:t>
+              <a:t>Dynamic automated pipeline refreshing solved DSA milestones and live repo activity.</a:t>
             </a:r>
           </a:p>
           <a:p>
             <a:pPr>
               <a:spcBef>
-                <a:spcPts val="600"/>
+                <a:spcPts val="800"/>
               </a:spcBef>
-              <a:defRPr sz="1250" b="1">
+              <a:defRPr sz="1300" b="1">
                 <a:solidFill>
                   <a:srgbClr val="0F172A"/>
                 </a:solidFill>
@@ -7006,7 +7356,7 @@
               </a:defRPr>
             </a:pPr>
             <a:r>
-              <a:t>→ Interactive RAG Playground</a:t>
+              <a:t>→ Interactive Semantic RAG Playground</a:t>
             </a:r>
           </a:p>
           <a:p>
@@ -7019,7 +7369,65 @@
               </a:defRPr>
             </a:pPr>
             <a:r>
-              <a:t>In-browser live demonstration of OpenAPI and YAML semantic vector retrieval.</a:t>
+              <a:t>In-browser live demonstration of OpenAPI and YAML semantic vector retrieval with LangChain.</a:t>
+            </a:r>
+          </a:p>
+          <a:p>
+            <a:pPr>
+              <a:spcBef>
+                <a:spcPts val="800"/>
+              </a:spcBef>
+              <a:defRPr sz="1300" b="1">
+                <a:solidFill>
+                  <a:srgbClr val="0F172A"/>
+                </a:solidFill>
+                <a:latin typeface="Outfit"/>
+              </a:defRPr>
+            </a:pPr>
+            <a:r>
+              <a:t>→ Automated Lighthouse CI Gates</a:t>
+            </a:r>
+          </a:p>
+          <a:p>
+            <a:pPr>
+              <a:defRPr sz="1050">
+                <a:solidFill>
+                  <a:srgbClr val="334155"/>
+                </a:solidFill>
+                <a:latin typeface="Inter"/>
+              </a:defRPr>
+            </a:pPr>
+            <a:r>
+              <a:t>Continuous integration checks enforcing 98+ accessibility, performance, and SEO scores on commits.</a:t>
+            </a:r>
+          </a:p>
+          <a:p>
+            <a:pPr>
+              <a:spcBef>
+                <a:spcPts val="800"/>
+              </a:spcBef>
+              <a:defRPr sz="1300" b="1">
+                <a:solidFill>
+                  <a:srgbClr val="0F172A"/>
+                </a:solidFill>
+                <a:latin typeface="Outfit"/>
+              </a:defRPr>
+            </a:pPr>
+            <a:r>
+              <a:t>→ Ambient WebGL Micro-Interactions</a:t>
+            </a:r>
+          </a:p>
+          <a:p>
+            <a:pPr>
+              <a:defRPr sz="1050">
+                <a:solidFill>
+                  <a:srgbClr val="334155"/>
+                </a:solidFill>
+                <a:latin typeface="Inter"/>
+              </a:defRPr>
+            </a:pPr>
+            <a:r>
+              <a:t>Subtle GPU-accelerated interactive canvas shaders for featured project case studies.</a:t>
             </a:r>
           </a:p>
         </p:txBody>
@@ -7067,27 +7475,43 @@
           </a:p>
         </p:txBody>
       </p:sp>
-      <p:sp>
-        <p:nvSpPr>
-          <p:cNvPr id="10" name="Rounded Rectangle 9"/>
+    </p:spTree>
+  </p:cSld>
+  <p:clrMapOvr>
+    <a:masterClrMapping/>
+  </p:clrMapOvr>
+</p:sld>
+</file>
+
+<file path=ppt/slides/slide7.xml><?xml version="1.0" encoding="utf-8"?>
+<p:sld xmlns:a="http://schemas.openxmlformats.org/drawingml/2006/main" xmlns:p="http://schemas.openxmlformats.org/presentationml/2006/main" xmlns:r="http://schemas.openxmlformats.org/officeDocument/2006/relationships">
+  <p:cSld>
+    <p:spTree>
+      <p:nvGrpSpPr>
+        <p:cNvPr id="1" name=""/>
+        <p:cNvGrpSpPr/>
+        <p:nvPr/>
+      </p:nvGrpSpPr>
+      <p:grpSpPr/>
+      <p:sp>
+        <p:nvSpPr>
+          <p:cNvPr id="2" name="Rectangle 1"/>
           <p:cNvSpPr/>
           <p:nvPr/>
         </p:nvSpPr>
         <p:spPr>
           <a:xfrm>
-            <a:off x="6492240" y="4206240"/>
-            <a:ext cx="4602175" cy="1645920"/>
-          </a:xfrm>
-          <a:prstGeom prst="roundRect">
+            <a:off x="0" y="0"/>
+            <a:ext cx="12191695" cy="6858000"/>
+          </a:xfrm>
+          <a:prstGeom prst="rect">
             <a:avLst/>
           </a:prstGeom>
           <a:solidFill>
-            <a:srgbClr val="EEF2FF"/>
+            <a:srgbClr val="F8FAFC"/>
           </a:solidFill>
-          <a:ln w="19050">
-            <a:solidFill>
-              <a:srgbClr val="4F46E5"/>
-            </a:solidFill>
+          <a:ln>
+            <a:noFill/>
           </a:ln>
         </p:spPr>
         <p:style>
@@ -7105,11 +7529,271 @@
           </a:fontRef>
         </p:style>
         <p:txBody>
+          <a:bodyPr rtlCol="0" anchor="ctr"/>
+          <a:lstStyle/>
+          <a:p>
+            <a:pPr algn="ctr"/>
+          </a:p>
+        </p:txBody>
+      </p:sp>
+      <p:sp>
+        <p:nvSpPr>
+          <p:cNvPr id="3" name="Rounded Rectangle 2"/>
+          <p:cNvSpPr/>
+          <p:nvPr/>
+        </p:nvSpPr>
+        <p:spPr>
+          <a:xfrm>
+            <a:off x="822960" y="777240"/>
+            <a:ext cx="10545775" cy="5303520"/>
+          </a:xfrm>
+          <a:prstGeom prst="roundRect">
+            <a:avLst/>
+          </a:prstGeom>
+          <a:solidFill>
+            <a:srgbClr val="FFFFFF"/>
+          </a:solidFill>
+          <a:ln w="12700">
+            <a:solidFill>
+              <a:srgbClr val="E2E8F0"/>
+            </a:solidFill>
+          </a:ln>
+        </p:spPr>
+        <p:style>
+          <a:lnRef idx="1">
+            <a:schemeClr val="accent1"/>
+          </a:lnRef>
+          <a:fillRef idx="3">
+            <a:schemeClr val="accent1"/>
+          </a:fillRef>
+          <a:effectRef idx="2">
+            <a:schemeClr val="accent1"/>
+          </a:effectRef>
+          <a:fontRef idx="minor">
+            <a:schemeClr val="lt1"/>
+          </a:fontRef>
+        </p:style>
+        <p:txBody>
+          <a:bodyPr rtlCol="0" anchor="ctr"/>
+          <a:lstStyle/>
+          <a:p>
+            <a:pPr algn="ctr"/>
+          </a:p>
+        </p:txBody>
+      </p:sp>
+      <p:sp>
+        <p:nvSpPr>
+          <p:cNvPr id="4" name="Rounded Rectangle 3"/>
+          <p:cNvSpPr/>
+          <p:nvPr/>
+        </p:nvSpPr>
+        <p:spPr>
+          <a:xfrm>
+            <a:off x="4037990" y="1143000"/>
+            <a:ext cx="4114800" cy="384048"/>
+          </a:xfrm>
+          <a:prstGeom prst="roundRect">
+            <a:avLst/>
+          </a:prstGeom>
+          <a:solidFill>
+            <a:srgbClr val="EEF2FF"/>
+          </a:solidFill>
+          <a:ln w="12700">
+            <a:solidFill>
+              <a:srgbClr val="93C5FD"/>
+            </a:solidFill>
+          </a:ln>
+        </p:spPr>
+        <p:style>
+          <a:lnRef idx="1">
+            <a:schemeClr val="accent1"/>
+          </a:lnRef>
+          <a:fillRef idx="3">
+            <a:schemeClr val="accent1"/>
+          </a:fillRef>
+          <a:effectRef idx="2">
+            <a:schemeClr val="accent1"/>
+          </a:effectRef>
+          <a:fontRef idx="minor">
+            <a:schemeClr val="lt1"/>
+          </a:fontRef>
+        </p:style>
+        <p:txBody>
+          <a:bodyPr rtlCol="0" anchor="ctr"/>
+          <a:lstStyle/>
+          <a:p>
+            <a:pPr algn="ctr">
+              <a:defRPr sz="950" b="1">
+                <a:solidFill>
+                  <a:srgbClr val="4F46E5"/>
+                </a:solidFill>
+                <a:latin typeface="JetBrains Mono"/>
+              </a:defRPr>
+            </a:pPr>
+            <a:r>
+              <a:t>CAPSTONE EVALUATION &amp; CONCLUSION</a:t>
+            </a:r>
+          </a:p>
+        </p:txBody>
+      </p:sp>
+      <p:sp>
+        <p:nvSpPr>
+          <p:cNvPr id="5" name="TextBox 4"/>
+          <p:cNvSpPr txBox="1"/>
+          <p:nvPr/>
+        </p:nvSpPr>
+        <p:spPr>
+          <a:xfrm>
+            <a:off x="1371600" y="1691640"/>
+            <a:ext cx="9448495" cy="1005840"/>
+          </a:xfrm>
+          <a:prstGeom prst="rect">
+            <a:avLst/>
+          </a:prstGeom>
+          <a:noFill/>
+        </p:spPr>
+        <p:txBody>
+          <a:bodyPr wrap="square">
+            <a:spAutoFit/>
+          </a:bodyPr>
+          <a:lstStyle/>
+          <a:p>
+            <a:pPr algn="ctr">
+              <a:defRPr sz="4400" b="1">
+                <a:solidFill>
+                  <a:srgbClr val="0F172A"/>
+                </a:solidFill>
+                <a:latin typeface="Outfit"/>
+              </a:defRPr>
+            </a:pPr>
+            <a:r>
+              <a:t>Thank You!</a:t>
+            </a:r>
+          </a:p>
+        </p:txBody>
+      </p:sp>
+      <p:sp>
+        <p:nvSpPr>
+          <p:cNvPr id="6" name="TextBox 5"/>
+          <p:cNvSpPr txBox="1"/>
+          <p:nvPr/>
+        </p:nvSpPr>
+        <p:spPr>
+          <a:xfrm>
+            <a:off x="1371600" y="2651760"/>
+            <a:ext cx="9448495" cy="548640"/>
+          </a:xfrm>
+          <a:prstGeom prst="rect">
+            <a:avLst/>
+          </a:prstGeom>
+          <a:noFill/>
+        </p:spPr>
+        <p:txBody>
+          <a:bodyPr wrap="square">
+            <a:spAutoFit/>
+          </a:bodyPr>
+          <a:lstStyle/>
+          <a:p>
+            <a:pPr algn="ctr">
+              <a:defRPr sz="1500" b="0">
+                <a:solidFill>
+                  <a:srgbClr val="334155"/>
+                </a:solidFill>
+                <a:latin typeface="Inter"/>
+              </a:defRPr>
+            </a:pPr>
+            <a:r>
+              <a:t>Open for Technical Questions, Architectural Discussions &amp; Feedback</a:t>
+            </a:r>
+          </a:p>
+        </p:txBody>
+      </p:sp>
+      <p:sp>
+        <p:nvSpPr>
+          <p:cNvPr id="7" name="Rectangle 6"/>
+          <p:cNvSpPr/>
+          <p:nvPr/>
+        </p:nvSpPr>
+        <p:spPr>
+          <a:xfrm>
+            <a:off x="2286000" y="3291840"/>
+            <a:ext cx="7619695" cy="18288"/>
+          </a:xfrm>
+          <a:prstGeom prst="rect">
+            <a:avLst/>
+          </a:prstGeom>
+          <a:solidFill>
+            <a:srgbClr val="E2E8F0"/>
+          </a:solidFill>
+          <a:ln>
+            <a:noFill/>
+          </a:ln>
+        </p:spPr>
+        <p:style>
+          <a:lnRef idx="1">
+            <a:schemeClr val="accent1"/>
+          </a:lnRef>
+          <a:fillRef idx="3">
+            <a:schemeClr val="accent1"/>
+          </a:fillRef>
+          <a:effectRef idx="2">
+            <a:schemeClr val="accent1"/>
+          </a:effectRef>
+          <a:fontRef idx="minor">
+            <a:schemeClr val="lt1"/>
+          </a:fontRef>
+        </p:style>
+        <p:txBody>
+          <a:bodyPr rtlCol="0" anchor="ctr"/>
+          <a:lstStyle/>
+          <a:p>
+            <a:pPr algn="ctr"/>
+          </a:p>
+        </p:txBody>
+      </p:sp>
+      <p:sp>
+        <p:nvSpPr>
+          <p:cNvPr id="8" name="Rounded Rectangle 7"/>
+          <p:cNvSpPr/>
+          <p:nvPr/>
+        </p:nvSpPr>
+        <p:spPr>
+          <a:xfrm>
+            <a:off x="1371600" y="3520440"/>
+            <a:ext cx="9448495" cy="868680"/>
+          </a:xfrm>
+          <a:prstGeom prst="roundRect">
+            <a:avLst/>
+          </a:prstGeom>
+          <a:solidFill>
+            <a:srgbClr val="F1F5F9"/>
+          </a:solidFill>
+          <a:ln w="12700">
+            <a:solidFill>
+              <a:srgbClr val="E2E8F0"/>
+            </a:solidFill>
+          </a:ln>
+        </p:spPr>
+        <p:style>
+          <a:lnRef idx="1">
+            <a:schemeClr val="accent1"/>
+          </a:lnRef>
+          <a:fillRef idx="3">
+            <a:schemeClr val="accent1"/>
+          </a:fillRef>
+          <a:effectRef idx="2">
+            <a:schemeClr val="accent1"/>
+          </a:effectRef>
+          <a:fontRef idx="minor">
+            <a:schemeClr val="lt1"/>
+          </a:fontRef>
+        </p:style>
+        <p:txBody>
           <a:bodyPr rtlCol="0" anchor="ctr" wrap="square"/>
           <a:lstStyle/>
           <a:p>
             <a:pPr algn="ctr">
-              <a:defRPr sz="2200" b="1">
+              <a:defRPr sz="1400" b="1">
                 <a:solidFill>
                   <a:srgbClr val="0F172A"/>
                 </a:solidFill>
@@ -7117,37 +7801,414 @@
               </a:defRPr>
             </a:pPr>
             <a:r>
-              <a:t>Thank You!</a:t>
+              <a:t>Swetha N.  ·  B.E. Computer Science and Design (Class of 2028)</a:t>
             </a:r>
           </a:p>
           <a:p>
             <a:pPr algn="ctr">
+              <a:spcBef>
+                <a:spcPts val="300"/>
+              </a:spcBef>
+              <a:defRPr sz="1100">
+                <a:solidFill>
+                  <a:srgbClr val="2563EB"/>
+                </a:solidFill>
+                <a:latin typeface="Inter"/>
+              </a:defRPr>
+            </a:pPr>
+            <a:r>
+              <a:t>Rajalakshmi Engineering College, Chennai  ·  CGPA: 8.65</a:t>
+            </a:r>
+          </a:p>
+        </p:txBody>
+      </p:sp>
+      <p:sp>
+        <p:nvSpPr>
+          <p:cNvPr id="9" name="Rounded Rectangle 8"/>
+          <p:cNvSpPr/>
+          <p:nvPr/>
+        </p:nvSpPr>
+        <p:spPr>
+          <a:xfrm>
+            <a:off x="1371600" y="4572000"/>
+            <a:ext cx="2956255" cy="1234440"/>
+          </a:xfrm>
+          <a:prstGeom prst="roundRect">
+            <a:avLst/>
+          </a:prstGeom>
+          <a:solidFill>
+            <a:srgbClr val="F1F5F9"/>
+          </a:solidFill>
+          <a:ln w="12700">
+            <a:solidFill>
+              <a:srgbClr val="E2E8F0"/>
+            </a:solidFill>
+          </a:ln>
+        </p:spPr>
+        <p:style>
+          <a:lnRef idx="1">
+            <a:schemeClr val="accent1"/>
+          </a:lnRef>
+          <a:fillRef idx="3">
+            <a:schemeClr val="accent1"/>
+          </a:fillRef>
+          <a:effectRef idx="2">
+            <a:schemeClr val="accent1"/>
+          </a:effectRef>
+          <a:fontRef idx="minor">
+            <a:schemeClr val="lt1"/>
+          </a:fontRef>
+        </p:style>
+        <p:txBody>
+          <a:bodyPr rtlCol="0" anchor="ctr" wrap="square"/>
+          <a:lstStyle/>
+          <a:p>
+            <a:pPr algn="ctr">
+              <a:defRPr sz="850" b="1">
+                <a:solidFill>
+                  <a:srgbClr val="059669"/>
+                </a:solidFill>
+                <a:latin typeface="JetBrains Mono"/>
+              </a:defRPr>
+            </a:pPr>
+            <a:r>
+              <a:t>LIVE DEPLOYMENT</a:t>
+            </a:r>
+          </a:p>
+          <a:p>
+            <a:pPr>
               <a:spcBef>
                 <a:spcPts val="400"/>
               </a:spcBef>
               <a:defRPr sz="1200" b="1">
                 <a:solidFill>
+                  <a:srgbClr val="0F172A"/>
+                </a:solidFill>
+                <a:latin typeface="Outfit"/>
+              </a:defRPr>
+            </a:pPr>
+            <a:r>
+              <a:t>Vercel Edge Platform</a:t>
+            </a:r>
+          </a:p>
+          <a:p>
+            <a:pPr>
+              <a:spcBef>
+                <a:spcPts val="200"/>
+              </a:spcBef>
+              <a:defRPr sz="950">
+                <a:solidFill>
+                  <a:srgbClr val="64748B"/>
+                </a:solidFill>
+                <a:latin typeface="JetBrains Mono"/>
+              </a:defRPr>
+            </a:pPr>
+            <a:r>
+              <a:t>my-portfolio-...vercel.app</a:t>
+            </a:r>
+          </a:p>
+        </p:txBody>
+      </p:sp>
+      <p:sp>
+        <p:nvSpPr>
+          <p:cNvPr id="10" name="Rectangle 9"/>
+          <p:cNvSpPr/>
+          <p:nvPr/>
+        </p:nvSpPr>
+        <p:spPr>
+          <a:xfrm>
+            <a:off x="1371600" y="4572000"/>
+            <a:ext cx="2956255" cy="36576"/>
+          </a:xfrm>
+          <a:prstGeom prst="rect">
+            <a:avLst/>
+          </a:prstGeom>
+          <a:solidFill>
+            <a:srgbClr val="059669"/>
+          </a:solidFill>
+          <a:ln>
+            <a:noFill/>
+          </a:ln>
+        </p:spPr>
+        <p:style>
+          <a:lnRef idx="1">
+            <a:schemeClr val="accent1"/>
+          </a:lnRef>
+          <a:fillRef idx="3">
+            <a:schemeClr val="accent1"/>
+          </a:fillRef>
+          <a:effectRef idx="2">
+            <a:schemeClr val="accent1"/>
+          </a:effectRef>
+          <a:fontRef idx="minor">
+            <a:schemeClr val="lt1"/>
+          </a:fontRef>
+        </p:style>
+        <p:txBody>
+          <a:bodyPr rtlCol="0" anchor="ctr"/>
+          <a:lstStyle/>
+          <a:p>
+            <a:pPr algn="ctr"/>
+          </a:p>
+        </p:txBody>
+      </p:sp>
+      <p:sp>
+        <p:nvSpPr>
+          <p:cNvPr id="11" name="Rounded Rectangle 10"/>
+          <p:cNvSpPr/>
+          <p:nvPr/>
+        </p:nvSpPr>
+        <p:spPr>
+          <a:xfrm>
+            <a:off x="4617720" y="4572000"/>
+            <a:ext cx="2956255" cy="1234440"/>
+          </a:xfrm>
+          <a:prstGeom prst="roundRect">
+            <a:avLst/>
+          </a:prstGeom>
+          <a:solidFill>
+            <a:srgbClr val="F1F5F9"/>
+          </a:solidFill>
+          <a:ln w="12700">
+            <a:solidFill>
+              <a:srgbClr val="E2E8F0"/>
+            </a:solidFill>
+          </a:ln>
+        </p:spPr>
+        <p:style>
+          <a:lnRef idx="1">
+            <a:schemeClr val="accent1"/>
+          </a:lnRef>
+          <a:fillRef idx="3">
+            <a:schemeClr val="accent1"/>
+          </a:fillRef>
+          <a:effectRef idx="2">
+            <a:schemeClr val="accent1"/>
+          </a:effectRef>
+          <a:fontRef idx="minor">
+            <a:schemeClr val="lt1"/>
+          </a:fontRef>
+        </p:style>
+        <p:txBody>
+          <a:bodyPr rtlCol="0" anchor="ctr" wrap="square"/>
+          <a:lstStyle/>
+          <a:p>
+            <a:pPr algn="ctr">
+              <a:defRPr sz="850" b="1">
+                <a:solidFill>
+                  <a:srgbClr val="4F46E5"/>
+                </a:solidFill>
+                <a:latin typeface="JetBrains Mono"/>
+              </a:defRPr>
+            </a:pPr>
+            <a:r>
+              <a:t>GITHUB REPOSITORY</a:t>
+            </a:r>
+          </a:p>
+          <a:p>
+            <a:pPr>
+              <a:spcBef>
+                <a:spcPts val="400"/>
+              </a:spcBef>
+              <a:defRPr sz="1200" b="1">
+                <a:solidFill>
+                  <a:srgbClr val="0F172A"/>
+                </a:solidFill>
+                <a:latin typeface="Outfit"/>
+              </a:defRPr>
+            </a:pPr>
+            <a:r>
+              <a:t>swethanagaraj2007</a:t>
+            </a:r>
+          </a:p>
+          <a:p>
+            <a:pPr>
+              <a:spcBef>
+                <a:spcPts val="200"/>
+              </a:spcBef>
+              <a:defRPr sz="950">
+                <a:solidFill>
+                  <a:srgbClr val="64748B"/>
+                </a:solidFill>
+                <a:latin typeface="JetBrains Mono"/>
+              </a:defRPr>
+            </a:pPr>
+            <a:r>
+              <a:t>github.com/swethanagaraj2007</a:t>
+            </a:r>
+          </a:p>
+        </p:txBody>
+      </p:sp>
+      <p:sp>
+        <p:nvSpPr>
+          <p:cNvPr id="12" name="Rectangle 11"/>
+          <p:cNvSpPr/>
+          <p:nvPr/>
+        </p:nvSpPr>
+        <p:spPr>
+          <a:xfrm>
+            <a:off x="4617720" y="4572000"/>
+            <a:ext cx="2956255" cy="36576"/>
+          </a:xfrm>
+          <a:prstGeom prst="rect">
+            <a:avLst/>
+          </a:prstGeom>
+          <a:solidFill>
+            <a:srgbClr val="4F46E5"/>
+          </a:solidFill>
+          <a:ln>
+            <a:noFill/>
+          </a:ln>
+        </p:spPr>
+        <p:style>
+          <a:lnRef idx="1">
+            <a:schemeClr val="accent1"/>
+          </a:lnRef>
+          <a:fillRef idx="3">
+            <a:schemeClr val="accent1"/>
+          </a:fillRef>
+          <a:effectRef idx="2">
+            <a:schemeClr val="accent1"/>
+          </a:effectRef>
+          <a:fontRef idx="minor">
+            <a:schemeClr val="lt1"/>
+          </a:fontRef>
+        </p:style>
+        <p:txBody>
+          <a:bodyPr rtlCol="0" anchor="ctr"/>
+          <a:lstStyle/>
+          <a:p>
+            <a:pPr algn="ctr"/>
+          </a:p>
+        </p:txBody>
+      </p:sp>
+      <p:sp>
+        <p:nvSpPr>
+          <p:cNvPr id="13" name="Rounded Rectangle 12"/>
+          <p:cNvSpPr/>
+          <p:nvPr/>
+        </p:nvSpPr>
+        <p:spPr>
+          <a:xfrm>
+            <a:off x="7863840" y="4572000"/>
+            <a:ext cx="2956255" cy="1234440"/>
+          </a:xfrm>
+          <a:prstGeom prst="roundRect">
+            <a:avLst/>
+          </a:prstGeom>
+          <a:solidFill>
+            <a:srgbClr val="F1F5F9"/>
+          </a:solidFill>
+          <a:ln w="12700">
+            <a:solidFill>
+              <a:srgbClr val="E2E8F0"/>
+            </a:solidFill>
+          </a:ln>
+        </p:spPr>
+        <p:style>
+          <a:lnRef idx="1">
+            <a:schemeClr val="accent1"/>
+          </a:lnRef>
+          <a:fillRef idx="3">
+            <a:schemeClr val="accent1"/>
+          </a:fillRef>
+          <a:effectRef idx="2">
+            <a:schemeClr val="accent1"/>
+          </a:effectRef>
+          <a:fontRef idx="minor">
+            <a:schemeClr val="lt1"/>
+          </a:fontRef>
+        </p:style>
+        <p:txBody>
+          <a:bodyPr rtlCol="0" anchor="ctr" wrap="square"/>
+          <a:lstStyle/>
+          <a:p>
+            <a:pPr algn="ctr">
+              <a:defRPr sz="850" b="1">
+                <a:solidFill>
                   <a:srgbClr val="2563EB"/>
                 </a:solidFill>
-                <a:latin typeface="Inter"/>
-              </a:defRPr>
-            </a:pPr>
-            <a:r>
-              <a:t>Swetha N. — B.E. Computer Science and Design</a:t>
-            </a:r>
-          </a:p>
-          <a:p>
-            <a:pPr algn="ctr">
-              <a:defRPr sz="1050">
-                <a:solidFill>
-                  <a:srgbClr val="334155"/>
-                </a:solidFill>
-                <a:latin typeface="Inter"/>
-              </a:defRPr>
-            </a:pPr>
-            <a:r>
-              <a:t>Rajalakshmi Engineering College · Chennai</a:t>
-            </a:r>
+                <a:latin typeface="JetBrains Mono"/>
+              </a:defRPr>
+            </a:pPr>
+            <a:r>
+              <a:t>PROFESSIONAL CONNECT</a:t>
+            </a:r>
+          </a:p>
+          <a:p>
+            <a:pPr>
+              <a:spcBef>
+                <a:spcPts val="400"/>
+              </a:spcBef>
+              <a:defRPr sz="1200" b="1">
+                <a:solidFill>
+                  <a:srgbClr val="0F172A"/>
+                </a:solidFill>
+                <a:latin typeface="Outfit"/>
+              </a:defRPr>
+            </a:pPr>
+            <a:r>
+              <a:t>LinkedIn Network</a:t>
+            </a:r>
+          </a:p>
+          <a:p>
+            <a:pPr>
+              <a:spcBef>
+                <a:spcPts val="200"/>
+              </a:spcBef>
+              <a:defRPr sz="950">
+                <a:solidFill>
+                  <a:srgbClr val="64748B"/>
+                </a:solidFill>
+                <a:latin typeface="JetBrains Mono"/>
+              </a:defRPr>
+            </a:pPr>
+            <a:r>
+              <a:t>linkedin.com/in/swetha-n-005697334</a:t>
+            </a:r>
+          </a:p>
+        </p:txBody>
+      </p:sp>
+      <p:sp>
+        <p:nvSpPr>
+          <p:cNvPr id="14" name="Rectangle 13"/>
+          <p:cNvSpPr/>
+          <p:nvPr/>
+        </p:nvSpPr>
+        <p:spPr>
+          <a:xfrm>
+            <a:off x="7863840" y="4572000"/>
+            <a:ext cx="2956255" cy="36576"/>
+          </a:xfrm>
+          <a:prstGeom prst="rect">
+            <a:avLst/>
+          </a:prstGeom>
+          <a:solidFill>
+            <a:srgbClr val="2563EB"/>
+          </a:solidFill>
+          <a:ln>
+            <a:noFill/>
+          </a:ln>
+        </p:spPr>
+        <p:style>
+          <a:lnRef idx="1">
+            <a:schemeClr val="accent1"/>
+          </a:lnRef>
+          <a:fillRef idx="3">
+            <a:schemeClr val="accent1"/>
+          </a:fillRef>
+          <a:effectRef idx="2">
+            <a:schemeClr val="accent1"/>
+          </a:effectRef>
+          <a:fontRef idx="minor">
+            <a:schemeClr val="lt1"/>
+          </a:fontRef>
+        </p:style>
+        <p:txBody>
+          <a:bodyPr rtlCol="0" anchor="ctr"/>
+          <a:lstStyle/>
+          <a:p>
+            <a:pPr algn="ctr"/>
           </a:p>
         </p:txBody>
       </p:sp>

</xml_diff>